<commit_message>
Remove Y220C from poster mutation list → 7 BQP-relevant targets
Y220C kept in platform as NGS demo anchor (MI25-0349) but removed
from the poster's scientific claim list — it has a PDB structure,
a known binding pocket, and Rezatapopt in Phase II (solved target).

https://claude.ai/code/session_01A9pq3irFsBbc4SXW67DKjF
</commit_message>
<xml_diff>
--- a/arxiv/IST697_Final_Poster.pptx
+++ b/arxiv/IST697_Final_Poster.pptx
@@ -2269,7 +2269,7 @@
                 <a:ea typeface="Calibri" pitchFamily="34" charset="-122"/>
                 <a:cs typeface="Calibri" pitchFamily="34" charset="-120"/>
               </a:rPr>
-              <a:t>. 3D molecular viewer · 8 non-druggable mutations · four-screen workflow.</a:t>
+              <a:t>. 3D molecular viewer · 7 non-druggable mutations · four-screen workflow.</a:t>
             </a:r>
             <a:endParaRPr lang="en-US" sz="2000" dirty="0"/>
           </a:p>
@@ -2323,7 +2323,7 @@
                 <a:ea typeface="Calibri" pitchFamily="34" charset="-122"/>
                 <a:cs typeface="Calibri" pitchFamily="34" charset="-120"/>
               </a:rPr>
-              <a:t> - TP53 C275F, TP53 Y220C, KEAP1 LOF, KEAP1 G333C, KEAP1 R320Q, STK11 LKB1, STK11 F354L, STK11 D194N</a:t>
+              <a:t> - TP53 C275F, KEAP1 LOF, KEAP1 G333C, KEAP1 R320Q, STK11 LKB1, STK11 F354L, STK11 D194N</a:t>
             </a:r>
             <a:endParaRPr lang="en-US" sz="2000" dirty="0"/>
           </a:p>
@@ -4143,7 +4143,7 @@
                 <a:ea typeface="Georgia" pitchFamily="34" charset="-122"/>
                 <a:cs typeface="Georgia" pitchFamily="34" charset="-120"/>
               </a:rPr>
-              <a:t>8</a:t>
+              <a:t>7</a:t>
             </a:r>
             <a:endParaRPr lang="en-US" sz="6400" dirty="0"/>
           </a:p>

</xml_diff>

<commit_message>
Poster medium fixes: sqDRIFT label, ΔE→ΔG, Vakili/KRAS contrast
- Results: VQE-sqDRIFT → sqDRIFT (Phase 3B target)
- Problem: DFT error aligned to 2-4 kcal/mol with ΔE→ΔG consequence
- Impact: new bullet — unlike quantum-enhanced KRAS (Vakili 2025),
  QC here is the only available computational path

https://claude.ai/code/session_01A9pq3irFsBbc4SXW67DKjF
</commit_message>
<xml_diff>
--- a/arxiv/IST697_Final_Poster.pptx
+++ b/arxiv/IST697_Final_Poster.pptx
@@ -1250,7 +1250,7 @@
                 <a:ea typeface="Calibri" pitchFamily="34" charset="-122"/>
                 <a:cs typeface="Calibri" pitchFamily="34" charset="-120"/>
               </a:rPr>
-              <a:t>: ±5–10 kcal/mol error; ≤2 kcal/mol required</a:t>
+              <a:t>: 2–4 kcal/mol error → ΔG shifts 5–6× → candidate misclassification</a:t>
             </a:r>
             <a:endParaRPr lang="en-US" sz="2000" dirty="0"/>
           </a:p>
@@ -3081,7 +3081,7 @@
                 <a:ea typeface="Calibri" pitchFamily="34" charset="-122"/>
                 <a:cs typeface="Calibri" pitchFamily="34" charset="-120"/>
               </a:rPr>
-              <a:t>*VQE-</a:t>
+              <a:t>*</a:t>
             </a:r>
             <a:r>
               <a:rPr lang="en-US" sz="2000" b="1" dirty="0" err="1">
@@ -3092,7 +3092,7 @@
                 <a:ea typeface="Calibri" pitchFamily="34" charset="-122"/>
                 <a:cs typeface="Calibri" pitchFamily="34" charset="-120"/>
               </a:rPr>
-              <a:t>sqDRIFT</a:t>
+              <a:t>sqDRIFT (Phase 3B target)</a:t>
             </a:r>
             <a:r>
               <a:rPr lang="en-US" sz="2000" b="1" dirty="0">
@@ -3778,6 +3778,82 @@
                 <a:cs typeface="Calibri" pitchFamily="34" charset="-120"/>
               </a:rPr>
               <a:t> for non-druggable oncology targets - reusable across mutation classes</a:t>
+            </a:r>
+            <a:endParaRPr lang="en-US" sz="2000" dirty="0"/>
+          </a:p>
+          <a:p>
+            <a:pPr marL="342900" indent="-342900">
+              <a:spcAft>
+                <a:spcPts val="400"/>
+              </a:spcAft>
+              <a:buSzPct val="100000"/>
+              <a:buChar char="•"/>
+            </a:pPr>
+            <a:r>
+              <a:rPr lang="en-US" sz="2000" dirty="0">
+                <a:solidFill>
+                  <a:srgbClr val="1F1409"/>
+                </a:solidFill>
+                <a:latin typeface="Calibri" pitchFamily="34" charset="0"/>
+                <a:ea typeface="Calibri" pitchFamily="34" charset="-122"/>
+                <a:cs typeface="Calibri" pitchFamily="34" charset="-120"/>
+              </a:rPr>
+              <a:t>Unlike quantum-</a:t>
+            </a:r>
+            <a:r>
+              <a:rPr lang="en-US" sz="2000" i="1" dirty="0">
+                <a:solidFill>
+                  <a:srgbClr val="1F1409"/>
+                </a:solidFill>
+                <a:latin typeface="Calibri" pitchFamily="34" charset="0"/>
+                <a:ea typeface="Calibri" pitchFamily="34" charset="-122"/>
+                <a:cs typeface="Calibri" pitchFamily="34" charset="-120"/>
+              </a:rPr>
+              <a:t>enhanced</a:t>
+            </a:r>
+            <a:r>
+              <a:rPr lang="en-US" sz="2000" dirty="0">
+                <a:solidFill>
+                  <a:srgbClr val="1F1409"/>
+                </a:solidFill>
+                <a:latin typeface="Calibri" pitchFamily="34" charset="0"/>
+                <a:ea typeface="Calibri" pitchFamily="34" charset="-122"/>
+                <a:cs typeface="Calibri" pitchFamily="34" charset="-120"/>
+              </a:rPr>
+              <a:t> approaches targeting classically-tractable proteins (e.g. KRAS — Vakili et al., </a:t>
+            </a:r>
+            <a:r>
+              <a:rPr lang="en-US" sz="2000" i="1" dirty="0">
+                <a:solidFill>
+                  <a:srgbClr val="1F1409"/>
+                </a:solidFill>
+                <a:latin typeface="Calibri" pitchFamily="34" charset="0"/>
+                <a:ea typeface="Calibri" pitchFamily="34" charset="-122"/>
+                <a:cs typeface="Calibri" pitchFamily="34" charset="-120"/>
+              </a:rPr>
+              <a:t>Nature Biotechnology</a:t>
+            </a:r>
+            <a:r>
+              <a:rPr lang="en-US" sz="2000" dirty="0">
+                <a:solidFill>
+                  <a:srgbClr val="1F1409"/>
+                </a:solidFill>
+                <a:latin typeface="Calibri" pitchFamily="34" charset="0"/>
+                <a:ea typeface="Calibri" pitchFamily="34" charset="-122"/>
+                <a:cs typeface="Calibri" pitchFamily="34" charset="-120"/>
+              </a:rPr>
+              <a:t> 2025), QC here is the </a:t>
+            </a:r>
+            <a:r>
+              <a:rPr lang="en-US" sz="2000" b="1" dirty="0">
+                <a:solidFill>
+                  <a:srgbClr val="1F1409"/>
+                </a:solidFill>
+                <a:latin typeface="Calibri" pitchFamily="34" charset="0"/>
+                <a:ea typeface="Calibri" pitchFamily="34" charset="-122"/>
+                <a:cs typeface="Calibri" pitchFamily="34" charset="-120"/>
+              </a:rPr>
+              <a:t>only available computational path</a:t>
             </a:r>
             <a:endParaRPr lang="en-US" sz="2000" dirty="0"/>
           </a:p>

</xml_diff>

<commit_message>
Poster minor fixes: mutation count label, chemical accuracy wording
- "5 mutations" label → "7 mutations" in prototype section
- "within threshold" → "within chemical accuracy" in results
- Add "Chemical accuracy threshold: ≤1 kcal/mol" to results footnote

https://claude.ai/code/session_01A9pq3irFsBbc4SXW67DKjF
</commit_message>
<xml_diff>
--- a/arxiv/IST697_Final_Poster.pptx
+++ b/arxiv/IST697_Final_Poster.pptx
@@ -2312,7 +2312,7 @@
                 <a:ea typeface="Calibri" pitchFamily="34" charset="-122"/>
                 <a:cs typeface="Calibri" pitchFamily="34" charset="-120"/>
               </a:rPr>
-              <a:t>5 mutations</a:t>
+              <a:t>7 mutations</a:t>
             </a:r>
             <a:r>
               <a:rPr lang="en-US" sz="2000" dirty="0">
@@ -3114,7 +3114,7 @@
                 <a:ea typeface="Calibri" pitchFamily="34" charset="-122"/>
                 <a:cs typeface="Calibri" pitchFamily="34" charset="-120"/>
               </a:rPr>
-              <a:t> −11.7 kcal/mol  (0.5 error - within threshold)</a:t>
+              <a:t> −11.7 kcal/mol  (0.5 error - within chemical accuracy)</a:t>
             </a:r>
             <a:endParaRPr lang="en-US" sz="2000" dirty="0"/>
           </a:p>
@@ -3211,7 +3211,7 @@
                 <a:latin typeface="Calibri" pitchFamily="34" charset="0"/>
                 <a:cs typeface="Calibri" pitchFamily="34" charset="-120"/>
               </a:rPr>
-              <a:t>*Illustrative figures</a:t>
+              <a:t>*Illustrative figures · Chemical accuracy threshold: ≤1 kcal/mol</a:t>
             </a:r>
             <a:endParaRPr lang="en-US" sz="1600" dirty="0"/>
           </a:p>

</xml_diff>

<commit_message>
Coordinate-verified active-space corrections: 7 targets, C275F uniqueness, KEAP1/STK11 fault-tolerant era
- Dissertation: fix 'eight mutations' → 'seven scientifically classified mutations across four genes'
  at §06.i (contributions) and §09 (significance); remove SMARCA4/RBM10/ARID1A (not in platform);
  correct Class A count to 4 (C275F, STK11 LKB1, F354L, D194N) and Class B to 3 (KEAP1);
  add Merz 2026 hardware-tier note with PDB sources (1U6D, 2FLU, 2WTK) to §09 paragraph
- Poster: fix 'full pocket' → 'full active site' (Text 56); update Phase 3B label to note
  C275F only on today's hardware; add KEAP1/STK11 fault-tolerant QPU (~2030+) · 152–310q · PDB-verified
- arXiv: PDF recompiled (2× pdflatex, 18 pages, clean)
- simulate.py: all 7 mutation configs with PDB-verified electron/qubit counts and hardware_era fields

https://claude.ai/code/session_01A9pq3irFsBbc4SXW67DKjF
</commit_message>
<xml_diff>
--- a/arxiv/IST697_Final_Poster.pptx
+++ b/arxiv/IST697_Final_Poster.pptx
@@ -3493,7 +3493,7 @@
                 <a:ea typeface="Calibri" pitchFamily="34" charset="-122"/>
                 <a:cs typeface="Calibri" pitchFamily="34" charset="-120"/>
               </a:rPr>
-              <a:t> - Full ~88-qubit active site · proven feasible (94q demonstrated, Merz et al. 2026)</a:t>
+              <a:t>Full ~88-qubit active site · C275F only · proven feasible (94q, Merz et al. 2026) · KEAP1/STK11: fault-tolerant QPU (~2030+) · 152–310q · PDB-verified</a:t>
             </a:r>
             <a:endParaRPr lang="en-US" sz="2000" dirty="0"/>
           </a:p>
@@ -4180,7 +4180,7 @@
                 <a:ea typeface="Calibri" pitchFamily="34" charset="-122"/>
                 <a:cs typeface="Calibri" pitchFamily="34" charset="-120"/>
               </a:rPr>
-              <a:t>Qubits at full pocket (IBM Heron r3 range)</a:t>
+              <a:t>Qubits at full active site (IBM Heron r3 range)</a:t>
             </a:r>
             <a:endParaRPr lang="en-US" sz="1600" dirty="0"/>
           </a:p>

</xml_diff>

<commit_message>
Update poster: Phase 3A live circuit, 4-qubit, PySCF JW Hamiltonian
</commit_message>
<xml_diff>
--- a/arxiv/IST697_Final_Poster.pptx
+++ b/arxiv/IST697_Final_Poster.pptx
@@ -3450,7 +3450,7 @@
                 <a:ea typeface="Calibri" pitchFamily="34" charset="-122"/>
                 <a:cs typeface="Calibri" pitchFamily="34" charset="-120"/>
               </a:rPr>
-              <a:t>Phase 3A · Simulator</a:t>
+              <a:t>Phase 3A · Live Circuit</a:t>
             </a:r>
             <a:r>
               <a:rPr lang="en-US" sz="2000" dirty="0">
@@ -3461,7 +3461,7 @@
                 <a:ea typeface="Calibri" pitchFamily="34" charset="-122"/>
                 <a:cs typeface="Calibri" pitchFamily="34" charset="-120"/>
               </a:rPr>
-              <a:t> - PennyLane · 2-qubit proxy active space · May-Aug 2026</a:t>
+              <a:t> - PennyLane · 4-qubit live VQE · PySCF JW Hamiltonian · May-Aug 2026</a:t>
             </a:r>
             <a:endParaRPr lang="en-US" sz="2000" dirty="0"/>
           </a:p>

</xml_diff>

<commit_message>
Add IBM $10B roadmap bullet to poster Phase 3B hardware section
https://claude.ai/code/session_01A9pq3irFsBbc4SXW67DKjF
</commit_message>
<xml_diff>
--- a/arxiv/IST697_Final_Poster.pptx
+++ b/arxiv/IST697_Final_Poster.pptx
@@ -2030,6 +2030,27 @@
               <a:t>Empirical anchor: 32-electron / 100-qubit C₁₃Cl₂ benchmark (Science 2026)</a:t>
             </a:r>
             <a:endParaRPr lang="en-US" dirty="0"/>
+          </a:p>
+          <a:p>
+            <a:pPr marL="342900" indent="-342900">
+              <a:spcAft>
+                <a:spcPts val="300"/>
+              </a:spcAft>
+              <a:buSzPct val="100000"/>
+              <a:buChar char="•"/>
+            </a:pPr>
+            <a:endParaRPr lang="en-US" dirty="0"/>
+            <a:r>
+              <a:rPr lang="en-US" dirty="0">
+                <a:solidFill>
+                  <a:srgbClr val="1F1409"/>
+                </a:solidFill>
+                <a:latin typeface="Calibri" pitchFamily="34" charset="0"/>
+                <a:ea typeface="Calibri" pitchFamily="34" charset="-122"/>
+                <a:cs typeface="Calibri" pitchFamily="34" charset="-120"/>
+              </a:rPr>
+              <a:t>IBM $10B roadmap · Starling 2029: 200 logical qubits · C275F (88q) within trajectory</a:t>
+            </a:r>
           </a:p>
         </p:txBody>
       </p:sp>

</xml_diff>

<commit_message>
Poster: fix live-site URL to solange-platform.bio, refresh QR, drop contact-mutant
- Replaced the outdated live-site URL (nsclc-quantum-viewer.netlify.app) with
  solange-platform.bio in both the header and the "→" link.
- Regenerated the QR code to encode https://solange-platform.bio (high ECC),
  replacing the old QR that pointed to the stale Netlify subdomain.
- "TP53 contact-mutant tumors" -> "TP53 structural-mutant tumors" in the Future
  Research note, matching the structural-mutant correction already made in the
  dissertation. SqDRIFT and the arXiv/venue anchor were already current on the poster.
</commit_message>
<xml_diff>
--- a/arxiv/IST697_Final_Poster.pptx
+++ b/arxiv/IST697_Final_Poster.pptx
@@ -900,7 +900,7 @@
                 <a:ea typeface="Calibri" pitchFamily="34" charset="-122"/>
                 <a:cs typeface="Calibri" pitchFamily="34" charset="-120"/>
               </a:rPr>
-              <a:t>nsclc-quantum-viewer</a:t>
+              <a:t>solange-platform</a:t>
             </a:r>
             <a:endParaRPr lang="en-US" sz="2000" dirty="0"/>
           </a:p>
@@ -917,36 +917,12 @@
                 <a:ea typeface="Calibri" pitchFamily="34" charset="-122"/>
                 <a:cs typeface="Calibri" pitchFamily="34" charset="-120"/>
               </a:rPr>
-              <a:t>.netlify.app</a:t>
+              <a:t>.bio</a:t>
             </a:r>
             <a:endParaRPr lang="en-US" sz="2000" dirty="0"/>
           </a:p>
         </p:txBody>
       </p:sp>
-      <p:pic>
-        <p:nvPicPr>
-          <p:cNvPr id="9" name="Image 2" descr="qrcode.jpg"/>
-          <p:cNvPicPr>
-            <a:picLocks noChangeAspect="1"/>
-          </p:cNvPicPr>
-          <p:nvPr/>
-        </p:nvPicPr>
-        <p:blipFill>
-          <a:blip r:embed="rId5"/>
-          <a:stretch>
-            <a:fillRect/>
-          </a:stretch>
-        </p:blipFill>
-        <p:spPr>
-          <a:xfrm>
-            <a:off x="30540960" y="1874520"/>
-            <a:ext cx="1828800" cy="1828800"/>
-          </a:xfrm>
-          <a:prstGeom prst="rect">
-            <a:avLst/>
-          </a:prstGeom>
-        </p:spPr>
-      </p:pic>
       <p:sp>
         <p:nvSpPr>
           <p:cNvPr id="10" name="Shape 5"/>
@@ -2511,7 +2487,7 @@
                 <a:ea typeface="Calibri" pitchFamily="34" charset="-122"/>
                 <a:cs typeface="Calibri" pitchFamily="34" charset="-120"/>
               </a:rPr>
-              <a:t>→ nsclc-quantum-viewer.netlify.app</a:t>
+              <a:t>→ solange-platform.bio</a:t>
             </a:r>
             <a:endParaRPr lang="en-US" sz="1600" dirty="0"/>
           </a:p>
@@ -4123,7 +4099,7 @@
                 <a:ea typeface="Calibri" pitchFamily="34" charset="-122"/>
                 <a:cs typeface="Calibri" pitchFamily="34" charset="-120"/>
               </a:rPr>
-              <a:t>quantum-derived mechanistic features for radioresistance in TP53 contact-mutant tumors. Reserved for a post-doctoral program extending the dissertation infrastructure into clinical decision support.</a:t>
+              <a:t>quantum-derived mechanistic features for radioresistance in TP53 structural-mutant tumors. Reserved for a post-doctoral program extending the dissertation infrastructure into clinical decision support.</a:t>
             </a:r>
             <a:endParaRPr lang="en-US" sz="1600" dirty="0"/>
           </a:p>
@@ -4567,6 +4543,30 @@
           </a:p>
         </p:txBody>
       </p:sp>
+      <p:pic>
+        <p:nvPicPr>
+          <p:cNvPr id="72" name="Picture 71" descr="solange_qr.png"/>
+          <p:cNvPicPr>
+            <a:picLocks noChangeAspect="1"/>
+          </p:cNvPicPr>
+          <p:nvPr/>
+        </p:nvPicPr>
+        <p:blipFill>
+          <a:blip r:embed="rId8"/>
+          <a:stretch>
+            <a:fillRect/>
+          </a:stretch>
+        </p:blipFill>
+        <p:spPr>
+          <a:xfrm>
+            <a:off x="30540960" y="1874520"/>
+            <a:ext cx="1828800" cy="1828800"/>
+          </a:xfrm>
+          <a:prstGeom prst="rect">
+            <a:avLst/>
+          </a:prstGeom>
+        </p:spPr>
+      </p:pic>
     </p:spTree>
   </p:cSld>
   <p:clrMapOvr>

</xml_diff>

<commit_message>
Poster: reframe target count as 7 validated core + 25+ extensible genes (option C)
Keeps the flagship 7 per-site-validated core mutations (TP53/KEAP1/STK11 variants)
but adds that the platform is extensible to 25+ tumor-suppressor genes via the
expansion pipeline (now including ARID2), so the poster no longer understates the
platform's actual scope. Updated the prototype line, the Layer-2 enumeration, and
the headline stat caption.
</commit_message>
<xml_diff>
--- a/arxiv/IST697_Final_Poster.pptx
+++ b/arxiv/IST697_Final_Poster.pptx
@@ -2266,7 +2266,7 @@
                 <a:ea typeface="Calibri" pitchFamily="34" charset="-122"/>
                 <a:cs typeface="Calibri" pitchFamily="34" charset="-120"/>
               </a:rPr>
-              <a:t>. 3D molecular viewer · 7 non-druggable mutations · four-screen workflow.</a:t>
+              <a:t>. 3D molecular viewer · 7 validated core mutations · four-screen workflow.</a:t>
             </a:r>
             <a:endParaRPr lang="en-US" sz="2000" dirty="0"/>
           </a:p>
@@ -2309,7 +2309,7 @@
                 <a:ea typeface="Calibri" pitchFamily="34" charset="-122"/>
                 <a:cs typeface="Calibri" pitchFamily="34" charset="-120"/>
               </a:rPr>
-              <a:t>7 mutations</a:t>
+              <a:t>7 core mutations</a:t>
             </a:r>
             <a:r>
               <a:rPr lang="en-US" sz="2000" dirty="0">
@@ -2320,7 +2320,7 @@
                 <a:ea typeface="Calibri" pitchFamily="34" charset="-122"/>
                 <a:cs typeface="Calibri" pitchFamily="34" charset="-120"/>
               </a:rPr>
-              <a:t> - TP53 C275F, KEAP1 LOF, KEAP1 G333C, KEAP1 R320Q, STK11 LKB1, STK11 F354L, STK11 D194N</a:t>
+              <a:t> - TP53 C275F, KEAP1 LOF, KEAP1 G333C, KEAP1 R320Q, STK11 LKB1, STK11 F354L, STK11 D194N; extensible to 25+ tumor-suppressor genes (expansion pipeline)</a:t>
             </a:r>
             <a:endParaRPr lang="en-US" sz="2000" dirty="0"/>
           </a:p>
@@ -4255,7 +4255,7 @@
                 <a:ea typeface="Calibri" pitchFamily="34" charset="-122"/>
                 <a:cs typeface="Calibri" pitchFamily="34" charset="-120"/>
               </a:rPr>
-              <a:t>non-druggable NSCLC mutations targeted</a:t>
+              <a:t>core non-druggable mutations · 25+ genes platform-wide</a:t>
             </a:r>
             <a:endParaRPr lang="en-US" sz="1600" dirty="0"/>
           </a:p>

</xml_diff>

<commit_message>
Add Heron r3 fidelity rationale + IBM sources to dissertation and poster
Reinforce WHY r3 (not just any Heron): r3 keeps r2's 156-qubit heavy-hex layout but
delivers IBM's best Heron coherence (~350 us T2) and improved gate/readout fidelity
(ibm_pittsburgh, released 2025). Since C275F's 88q site already fits r2's qubit count,
the binding-relevant constraint is lower ERROR, not more qubits — which is exactly
r3's improvement.
- Dissertation §1.4: added the fidelity-not-capacity paragraph + refs [58] IBM Quantum
  'Processor types' and [59] 'Nighthawk and the latest Heron are now available'.
- Poster: appended '~350 us T2, improved gate/readout fidelity (r3 ibm_pittsburgh,
  IBM Quantum 2026)' to the Heron line + a compact IBM source note.
Verified against IBM Quantum docs/announcements (Heron r3 = real released product).

Co-Authored-By: Claude Opus 4.8 <noreply@anthropic.com>
Claude-Session: https://claude.ai/code/session_01A9pq3irFsBbc4SXW67DKjF
</commit_message>
<xml_diff>
--- a/arxiv/IST697_Final_Poster.pptx
+++ b/arxiv/IST697_Final_Poster.pptx
@@ -1950,7 +1950,7 @@
                 <a:ea typeface="Calibri" pitchFamily="34" charset="-122"/>
                 <a:cs typeface="Calibri" pitchFamily="34" charset="-120"/>
               </a:rPr>
-              <a:t>IBM Heron r3 · 156 qubits · heavy-hex lattice</a:t>
+              <a:t>IBM Heron r3 · 156 qubits · heavy-hex lattice · ~350 µs T2, improved gate/readout fidelity (r3 ibm_pittsburgh, IBM Quantum 2026)</a:t>
             </a:r>
             <a:endParaRPr lang="en-US" dirty="0"/>
           </a:p>
@@ -2026,6 +2026,11 @@
                 <a:cs typeface="Calibri" pitchFamily="34" charset="-120"/>
               </a:rPr>
               <a:t>IBM $10B+ roadmap · Starling 2029: 200 logical qubits · C275F (88q) within trajectory</a:t>
+            </a:r>
+          </a:p>
+          <a:p>
+            <a:r>
+              <a:t>Heron r3 spec: IBM Quantum, Processor types &amp; 2026-01 product update (ibm_pittsburgh).</a:t>
             </a:r>
           </a:p>
         </p:txBody>

</xml_diff>

<commit_message>
Update IST697 poster with real Laguna measurements and consistency fixes
Replaces stale 44e/88q figures and placeholder content with real,
verified numbers from tonight's AVAS/DMRG runs on Laguna (USC CARC):
8/8 measured targets Class B, real active-space sizes for KEAP1/STK11,
R175H's final (not provisional) classification, and Phase 3A's real
LEON-sealed 20e/40q HPC record. Also fixes internal inconsistencies
(non-druggable wording, headline stat mismatches, fictional Nvidia
CUDA-Q/NVQLink claims replaced with what actually ran on Laguna) and
two layout-overflow bugs from earlier edits.

Co-Authored-By: Claude Sonnet 5 <noreply@anthropic.com>
Claude-Session: https://claude.ai/code/session_01A9pq3irFsBbc4SXW67DKjF
</commit_message>
<xml_diff>
--- a/arxiv/IST697_Final_Poster.pptx
+++ b/arxiv/IST697_Final_Poster.pptx
@@ -700,7 +700,7 @@
         </p:blipFill>
         <p:spPr>
           <a:xfrm>
-            <a:off x="457200" y="365760"/>
+            <a:off x="457200" y="182878"/>
             <a:ext cx="4023360" cy="1463040"/>
           </a:xfrm>
           <a:prstGeom prst="rect">
@@ -723,8 +723,8 @@
         </p:blipFill>
         <p:spPr>
           <a:xfrm>
-            <a:off x="457200" y="1874520"/>
-            <a:ext cx="4023360" cy="1554480"/>
+            <a:off x="457200" y="1640726"/>
+            <a:ext cx="4023360" cy="1337801"/>
           </a:xfrm>
           <a:prstGeom prst="rect">
             <a:avLst/>
@@ -784,7 +784,7 @@
                 </a:solidFill>
                 <a:latin typeface="Georgia" pitchFamily="34" charset="0"/>
               </a:rPr>
-              <a:t> for Quantum Simulation of non-druggable NSCLC Tumor Suppressor Mutations</a:t>
+              <a:t> for Quantum Simulation of Non-druggable NSCLC Tumor Suppressor Mutations</a:t>
             </a:r>
           </a:p>
         </p:txBody>
@@ -875,8 +875,8 @@
         </p:nvSpPr>
         <p:spPr>
           <a:xfrm>
-            <a:off x="27432000" y="868680"/>
-            <a:ext cx="5029200" cy="914400"/>
+            <a:off x="30284287" y="1051560"/>
+            <a:ext cx="2342146" cy="914400"/>
           </a:xfrm>
           <a:prstGeom prst="rect">
             <a:avLst/>
@@ -888,11 +888,11 @@
           <a:bodyPr wrap="square" lIns="0" tIns="0" rIns="0" bIns="0" rtlCol="0" anchor="ctr"/>
           <a:lstStyle/>
           <a:p>
-            <a:pPr marL="0" indent="0" algn="r">
+            <a:pPr marL="0" indent="0">
               <a:buNone/>
             </a:pPr>
             <a:r>
-              <a:rPr lang="en-US" sz="2000" b="1" dirty="0">
+              <a:rPr lang="en-US" sz="2000" b="1" dirty="0" err="1">
                 <a:solidFill>
                   <a:srgbClr val="1F1409"/>
                 </a:solidFill>
@@ -902,14 +902,8 @@
               </a:rPr>
               <a:t>solange-platform</a:t>
             </a:r>
-            <a:endParaRPr lang="en-US" sz="2000" dirty="0"/>
-          </a:p>
-          <a:p>
-            <a:pPr marL="0" indent="0" algn="r">
-              <a:buNone/>
-            </a:pPr>
-            <a:r>
-              <a:rPr lang="en-US" sz="2000" b="1" dirty="0">
+            <a:r>
+              <a:rPr lang="en-US" sz="2000" b="1" dirty="0" err="1">
                 <a:solidFill>
                   <a:srgbClr val="C75A2E"/>
                 </a:solidFill>
@@ -961,7 +955,7 @@
         </p:nvSpPr>
         <p:spPr>
           <a:xfrm>
-            <a:off x="457200" y="4114800"/>
+            <a:off x="558437" y="4121334"/>
             <a:ext cx="9601200" cy="6492240"/>
           </a:xfrm>
           <a:prstGeom prst="rect">
@@ -981,6 +975,7 @@
           <a:bodyPr/>
           <a:lstStyle/>
           <a:p>
+            <a:pPr marL="0" algn="l" defTabSz="914400" rtl="0" eaLnBrk="1" latinLnBrk="0" hangingPunct="1"/>
             <a:endParaRPr lang="en-US"/>
           </a:p>
         </p:txBody>
@@ -1033,7 +1028,7 @@
         <p:spPr>
           <a:xfrm>
             <a:off x="868680" y="4841126"/>
-            <a:ext cx="8961120" cy="1828800"/>
+            <a:ext cx="8961120" cy="1004621"/>
           </a:xfrm>
           <a:prstGeom prst="rect">
             <a:avLst/>
@@ -1065,12 +1060,10 @@
               </a:rPr>
               <a:t> TP53 mutations</a:t>
             </a:r>
-            <a:endParaRPr lang="en-US" sz="2800" dirty="0"/>
-          </a:p>
-          <a:p>
-            <a:pPr marL="0" indent="0">
-              <a:buNone/>
-            </a:pPr>
+            <a:r>
+              <a:rPr lang="en-US" sz="2800" dirty="0"/>
+              <a:t> </a:t>
+            </a:r>
             <a:r>
               <a:rPr lang="en-US" sz="2800" b="1" dirty="0">
                 <a:solidFill>
@@ -1111,7 +1104,7 @@
         </p:nvSpPr>
         <p:spPr>
           <a:xfrm>
-            <a:off x="777240" y="6343158"/>
+            <a:off x="777240" y="5729197"/>
             <a:ext cx="8961120" cy="1691640"/>
           </a:xfrm>
           <a:prstGeom prst="rect">
@@ -1186,7 +1179,7 @@
         </p:nvSpPr>
         <p:spPr>
           <a:xfrm>
-            <a:off x="777240" y="7975164"/>
+            <a:off x="777240" y="7269762"/>
             <a:ext cx="8961120" cy="1371600"/>
           </a:xfrm>
           <a:prstGeom prst="rect">
@@ -1226,7 +1219,29 @@
                 <a:ea typeface="Calibri" pitchFamily="34" charset="-122"/>
                 <a:cs typeface="Calibri" pitchFamily="34" charset="-120"/>
               </a:rPr>
-              <a:t>: 2–4 kcal/mol error → ΔG shifts 5–6× → candidate misclassification</a:t>
+              <a:t>: 2-4 kcal/mol error → ΔG shifts x5</a:t>
+            </a:r>
+            <a:r>
+              <a:rPr lang="he-IL" sz="2000" dirty="0">
+                <a:solidFill>
+                  <a:srgbClr val="1F1409"/>
+                </a:solidFill>
+                <a:latin typeface="Calibri" pitchFamily="34" charset="0"/>
+                <a:ea typeface="Calibri" pitchFamily="34" charset="-122"/>
+                <a:cs typeface="Calibri" pitchFamily="34" charset="-120"/>
+              </a:rPr>
+              <a:t>-</a:t>
+            </a:r>
+            <a:r>
+              <a:rPr lang="en-US" sz="2000" dirty="0">
+                <a:solidFill>
+                  <a:srgbClr val="1F1409"/>
+                </a:solidFill>
+                <a:latin typeface="Calibri" pitchFamily="34" charset="0"/>
+                <a:ea typeface="Calibri" pitchFamily="34" charset="-122"/>
+                <a:cs typeface="Calibri" pitchFamily="34" charset="-120"/>
+              </a:rPr>
+              <a:t>6 → candidate misclassification</a:t>
             </a:r>
             <a:endParaRPr lang="en-US" sz="2000" dirty="0"/>
           </a:p>
@@ -1258,7 +1273,7 @@
                 <a:ea typeface="Calibri" pitchFamily="34" charset="-122"/>
                 <a:cs typeface="Calibri" pitchFamily="34" charset="-120"/>
               </a:rPr>
-              <a:t>: gold standard, but O(N⁷) infeasible at 44 active electrons</a:t>
+              <a:t>: gold standard, but O(N⁷) infeasible at 48 active electrons</a:t>
             </a:r>
             <a:endParaRPr lang="en-US" sz="2000" dirty="0"/>
           </a:p>
@@ -1290,7 +1305,7 @@
                 <a:ea typeface="Calibri" pitchFamily="34" charset="-122"/>
                 <a:cs typeface="Calibri" pitchFamily="34" charset="-120"/>
               </a:rPr>
-              <a:t>: O(2ⁿ) ~ 10¹³ ops at N=44 - intractable</a:t>
+              <a:t>: O(2ⁿ) ~ 10¹³ ops at N=48 - intractable</a:t>
             </a:r>
             <a:endParaRPr lang="en-US" sz="2000" dirty="0"/>
           </a:p>
@@ -1304,8 +1319,8 @@
         </p:nvSpPr>
         <p:spPr>
           <a:xfrm>
-            <a:off x="777240" y="9584500"/>
-            <a:ext cx="8048708" cy="958532"/>
+            <a:off x="777240" y="8787384"/>
+            <a:ext cx="9304020" cy="1507451"/>
           </a:xfrm>
           <a:prstGeom prst="rect">
             <a:avLst/>
@@ -1319,6 +1334,7 @@
           <a:bodyPr/>
           <a:lstStyle/>
           <a:p>
+            <a:pPr marL="0" algn="r" defTabSz="914400" rtl="1" eaLnBrk="1" latinLnBrk="0" hangingPunct="1"/>
             <a:endParaRPr lang="en-US"/>
           </a:p>
         </p:txBody>
@@ -1459,7 +1475,7 @@
                 <a:ea typeface="Calibri" pitchFamily="34" charset="-122"/>
                 <a:cs typeface="Calibri" pitchFamily="34" charset="-120"/>
               </a:rPr>
-              <a:t>NGS PATIENT INPUT*  </a:t>
+              <a:t>NGS PATIENT INPUT  </a:t>
             </a:r>
             <a:r>
               <a:rPr lang="en-US" dirty="0">
@@ -1579,12 +1595,13 @@
           <a:bodyPr wrap="square" lIns="0" tIns="0" rIns="0" bIns="0" rtlCol="0" anchor="ctr"/>
           <a:lstStyle/>
           <a:p>
-            <a:pPr marL="342900" indent="-342900">
+            <a:pPr marL="285750" indent="-285750">
               <a:spcAft>
                 <a:spcPts val="300"/>
               </a:spcAft>
               <a:buSzPct val="100000"/>
-              <a:buChar char="◆"/>
+              <a:buFont typeface="Arial" panose="020B0604020202020204" pitchFamily="34" charset="0"/>
+              <a:buChar char="•"/>
             </a:pPr>
             <a:r>
               <a:rPr lang="en-US" dirty="0">
@@ -1595,17 +1612,18 @@
                 <a:ea typeface="Calibri" pitchFamily="34" charset="-122"/>
                 <a:cs typeface="Calibri" pitchFamily="34" charset="-120"/>
               </a:rPr>
-              <a:t>BQP-relevance classification framework - non-druggable tumor-suppressor mutations (§06.i)</a:t>
+              <a:t>BQP-relevance classification framework - non-druggable tumor-suppressor mutations </a:t>
             </a:r>
             <a:endParaRPr lang="en-US" dirty="0"/>
           </a:p>
           <a:p>
-            <a:pPr marL="342900" indent="-342900">
+            <a:pPr marL="285750" indent="-285750">
               <a:spcAft>
                 <a:spcPts val="300"/>
               </a:spcAft>
               <a:buSzPct val="100000"/>
-              <a:buChar char="◆"/>
+              <a:buFont typeface="Arial" panose="020B0604020202020204" pitchFamily="34" charset="0"/>
+              <a:buChar char="•"/>
             </a:pPr>
             <a:r>
               <a:rPr lang="en-US" dirty="0">
@@ -1616,17 +1634,18 @@
                 <a:ea typeface="Calibri" pitchFamily="34" charset="-122"/>
                 <a:cs typeface="Calibri" pitchFamily="34" charset="-120"/>
               </a:rPr>
-              <a:t>Translational orchestration - oncology-specific · Part-11-governed · bifurcation-aware (§06.ii)</a:t>
+              <a:t>Translational orchestration - oncology-specific · Part-11-governed · bifurcation-aware </a:t>
             </a:r>
             <a:endParaRPr lang="en-US" dirty="0"/>
           </a:p>
           <a:p>
-            <a:pPr marL="342900" indent="-342900">
+            <a:pPr marL="285750" indent="-285750">
               <a:spcAft>
                 <a:spcPts val="300"/>
               </a:spcAft>
               <a:buSzPct val="100000"/>
-              <a:buChar char="◆"/>
+              <a:buFont typeface="Arial" panose="020B0604020202020204" pitchFamily="34" charset="0"/>
+              <a:buChar char="•"/>
             </a:pPr>
             <a:r>
               <a:rPr lang="en-US" dirty="0">
@@ -1637,7 +1656,7 @@
                 <a:ea typeface="Calibri" pitchFamily="34" charset="-122"/>
                 <a:cs typeface="Calibri" pitchFamily="34" charset="-120"/>
               </a:rPr>
-              <a:t>FDA 21 CFR Part 11 framework with ML-decoder provenance, P1 - P9 (§06.iii)</a:t>
+              <a:t>FDA 21 CFR Part 11 framework with ML-decoder provenance, P1 - P9 </a:t>
             </a:r>
             <a:endParaRPr lang="en-US" dirty="0"/>
           </a:p>
@@ -1746,11 +1765,12 @@
           <a:bodyPr wrap="square" lIns="0" tIns="0" rIns="0" bIns="0" rtlCol="0" anchor="ctr"/>
           <a:lstStyle/>
           <a:p>
-            <a:pPr marL="342900" indent="-342900">
+            <a:pPr marL="285750" indent="-285750">
               <a:spcAft>
                 <a:spcPts val="300"/>
               </a:spcAft>
               <a:buSzPct val="100000"/>
+              <a:buFont typeface="Arial" panose="020B0604020202020204" pitchFamily="34" charset="0"/>
               <a:buChar char="•"/>
             </a:pPr>
             <a:r>
@@ -1762,16 +1782,16 @@
                 <a:ea typeface="Calibri" pitchFamily="34" charset="-122"/>
                 <a:cs typeface="Calibri" pitchFamily="34" charset="-120"/>
               </a:rPr>
-              <a:t>Hybrid orchestration - CUDA-Q + NVQLink (Nvidia stack)</a:t>
-            </a:r>
-            <a:endParaRPr lang="en-US" dirty="0"/>
-          </a:p>
-          <a:p>
-            <a:pPr marL="342900" indent="-342900">
+              <a:t>HPC orchestration - pull-based agent, USC CARC 'Laguna' · no stored credentials</a:t>
+            </a:r>
+          </a:p>
+          <a:p>
+            <a:pPr marL="285750" indent="-285750">
               <a:spcAft>
                 <a:spcPts val="300"/>
               </a:spcAft>
               <a:buSzPct val="100000"/>
+              <a:buFont typeface="Arial" panose="020B0604020202020204" pitchFamily="34" charset="0"/>
               <a:buChar char="•"/>
             </a:pPr>
             <a:r>
@@ -1783,16 +1803,60 @@
                 <a:ea typeface="Calibri" pitchFamily="34" charset="-122"/>
                 <a:cs typeface="Calibri" pitchFamily="34" charset="-120"/>
               </a:rPr>
-              <a:t>Quantum reliability - Nvidia Ising VLM calibration · 3D CNN decoder (Apr 2026)</a:t>
-            </a:r>
-            <a:endParaRPr lang="en-US" dirty="0"/>
-          </a:p>
-          <a:p>
-            <a:pPr marL="342900" indent="-342900">
+              <a:t>Active-space selection - AVAS (</a:t>
+            </a:r>
+            <a:r>
+              <a:rPr lang="en-US" dirty="0" err="1">
+                <a:solidFill>
+                  <a:srgbClr val="1F1409"/>
+                </a:solidFill>
+                <a:latin typeface="Calibri" pitchFamily="34" charset="0"/>
+                <a:ea typeface="Calibri" pitchFamily="34" charset="-122"/>
+                <a:cs typeface="Calibri" pitchFamily="34" charset="-120"/>
+              </a:rPr>
+              <a:t>PySCF</a:t>
+            </a:r>
+            <a:r>
+              <a:rPr lang="en-US" dirty="0">
+                <a:solidFill>
+                  <a:srgbClr val="1F1409"/>
+                </a:solidFill>
+                <a:latin typeface="Calibri" pitchFamily="34" charset="0"/>
+                <a:ea typeface="Calibri" pitchFamily="34" charset="-122"/>
+                <a:cs typeface="Calibri" pitchFamily="34" charset="-120"/>
+              </a:rPr>
+              <a:t>), </a:t>
+            </a:r>
+            <a:r>
+              <a:rPr lang="en-US" dirty="0" err="1">
+                <a:solidFill>
+                  <a:srgbClr val="1F1409"/>
+                </a:solidFill>
+                <a:latin typeface="Calibri" pitchFamily="34" charset="0"/>
+                <a:ea typeface="Calibri" pitchFamily="34" charset="-122"/>
+                <a:cs typeface="Calibri" pitchFamily="34" charset="-120"/>
+              </a:rPr>
+              <a:t>RDKit</a:t>
+            </a:r>
+            <a:r>
+              <a:rPr lang="en-US" dirty="0">
+                <a:solidFill>
+                  <a:srgbClr val="1F1409"/>
+                </a:solidFill>
+                <a:latin typeface="Calibri" pitchFamily="34" charset="0"/>
+                <a:ea typeface="Calibri" pitchFamily="34" charset="-122"/>
+                <a:cs typeface="Calibri" pitchFamily="34" charset="-120"/>
+              </a:rPr>
+              <a:t>-built fragments from real PDB coords</a:t>
+            </a:r>
+          </a:p>
+          <a:p>
+            <a:pPr marL="285750" indent="-285750">
               <a:spcAft>
                 <a:spcPts val="300"/>
               </a:spcAft>
               <a:buSzPct val="100000"/>
+              <a:buFont typeface="Arial" panose="020B0604020202020204" pitchFamily="34" charset="0"/>
               <a:buChar char="•"/>
             </a:pPr>
             <a:r>
@@ -1804,16 +1868,60 @@
                 <a:ea typeface="Calibri" pitchFamily="34" charset="-122"/>
                 <a:cs typeface="Calibri" pitchFamily="34" charset="-120"/>
               </a:rPr>
-              <a:t>Input prep - DFT (PySCF) · DMRG baseline + non-active-space treatment</a:t>
-            </a:r>
-            <a:endParaRPr lang="en-US" dirty="0"/>
-          </a:p>
-          <a:p>
-            <a:pPr marL="342900" indent="-342900">
+              <a:t>Classical-tractability classifier - block2 DMRG, </a:t>
+            </a:r>
+            <a:r>
+              <a:rPr lang="el-GR" dirty="0">
+                <a:solidFill>
+                  <a:srgbClr val="1F1409"/>
+                </a:solidFill>
+                <a:latin typeface="Calibri" pitchFamily="34" charset="0"/>
+                <a:ea typeface="Calibri" pitchFamily="34" charset="-122"/>
+                <a:cs typeface="Calibri" pitchFamily="34" charset="-120"/>
+              </a:rPr>
+              <a:t>Δ</a:t>
+            </a:r>
+            <a:r>
+              <a:rPr lang="en-US" dirty="0">
+                <a:solidFill>
+                  <a:srgbClr val="1F1409"/>
+                </a:solidFill>
+                <a:latin typeface="Calibri" pitchFamily="34" charset="0"/>
+                <a:ea typeface="Calibri" pitchFamily="34" charset="-122"/>
+                <a:cs typeface="Calibri" pitchFamily="34" charset="-120"/>
+              </a:rPr>
+              <a:t>E&lt;1.6 </a:t>
+            </a:r>
+            <a:r>
+              <a:rPr lang="en-US" dirty="0" err="1">
+                <a:solidFill>
+                  <a:srgbClr val="1F1409"/>
+                </a:solidFill>
+                <a:latin typeface="Calibri" pitchFamily="34" charset="0"/>
+                <a:ea typeface="Calibri" pitchFamily="34" charset="-122"/>
+                <a:cs typeface="Calibri" pitchFamily="34" charset="-120"/>
+              </a:rPr>
+              <a:t>mHa</a:t>
+            </a:r>
+            <a:r>
+              <a:rPr lang="en-US" dirty="0">
+                <a:solidFill>
+                  <a:srgbClr val="1F1409"/>
+                </a:solidFill>
+                <a:latin typeface="Calibri" pitchFamily="34" charset="0"/>
+                <a:ea typeface="Calibri" pitchFamily="34" charset="-122"/>
+                <a:cs typeface="Calibri" pitchFamily="34" charset="-120"/>
+              </a:rPr>
+              <a:t> convergence</a:t>
+            </a:r>
+          </a:p>
+          <a:p>
+            <a:pPr marL="285750" indent="-285750">
               <a:spcAft>
                 <a:spcPts val="300"/>
               </a:spcAft>
               <a:buSzPct val="100000"/>
+              <a:buFont typeface="Arial" panose="020B0604020202020204" pitchFamily="34" charset="0"/>
               <a:buChar char="•"/>
             </a:pPr>
             <a:r>
@@ -1825,7 +1933,7 @@
                 <a:ea typeface="Calibri" pitchFamily="34" charset="-122"/>
                 <a:cs typeface="Calibri" pitchFamily="34" charset="-120"/>
               </a:rPr>
-              <a:t>Output interpretation - DeepChem GNN clinical relevance scoring</a:t>
+              <a:t>Quantum execution - PennyLane VQE (3A) · IBM Heron r3 (3B)</a:t>
             </a:r>
             <a:endParaRPr lang="en-US" dirty="0"/>
           </a:p>
@@ -1840,7 +1948,7 @@
         <p:spPr>
           <a:xfrm>
             <a:off x="10561320" y="8951976"/>
-            <a:ext cx="11795760" cy="1371600"/>
+            <a:ext cx="11795760" cy="1563624"/>
           </a:xfrm>
           <a:prstGeom prst="rect">
             <a:avLst/>
@@ -1871,7 +1979,7 @@
         </p:nvSpPr>
         <p:spPr>
           <a:xfrm>
-            <a:off x="10725912" y="8997696"/>
+            <a:off x="10725912" y="8948080"/>
             <a:ext cx="11521440" cy="365760"/>
           </a:xfrm>
           <a:prstGeom prst="rect">
@@ -1921,8 +2029,8 @@
         </p:nvSpPr>
         <p:spPr>
           <a:xfrm>
-            <a:off x="10725912" y="9363456"/>
-            <a:ext cx="11521440" cy="914400"/>
+            <a:off x="10725912" y="9205633"/>
+            <a:ext cx="10801678" cy="1247263"/>
           </a:xfrm>
           <a:prstGeom prst="rect">
             <a:avLst/>
@@ -1942,17 +2050,60 @@
               <a:buChar char="•"/>
             </a:pPr>
             <a:r>
-              <a:rPr lang="en-US" dirty="0">
-                <a:solidFill>
-                  <a:srgbClr val="1F1409"/>
-                </a:solidFill>
-                <a:latin typeface="Calibri" pitchFamily="34" charset="0"/>
-                <a:ea typeface="Calibri" pitchFamily="34" charset="-122"/>
-                <a:cs typeface="Calibri" pitchFamily="34" charset="-120"/>
-              </a:rPr>
-              <a:t>IBM Heron r3 · 156 qubits · heavy-hex lattice · ~350 µs T2, improved gate/readout fidelity (r3 ibm_pittsburgh, IBM Quantum 2026)</a:t>
-            </a:r>
-            <a:endParaRPr lang="en-US" dirty="0"/>
+              <a:rPr lang="en-US" sz="1600" dirty="0">
+                <a:solidFill>
+                  <a:srgbClr val="1F1409"/>
+                </a:solidFill>
+                <a:latin typeface="Calibri" pitchFamily="34" charset="0"/>
+                <a:ea typeface="Calibri" pitchFamily="34" charset="-122"/>
+                <a:cs typeface="Calibri" pitchFamily="34" charset="-120"/>
+              </a:rPr>
+              <a:t>IBM Heron r3 · 156 qubits · heavy-hex lattice · improved gate/readout fidelity (IBM Quantum 2026,</a:t>
+            </a:r>
+            <a:r>
+              <a:rPr lang="he-IL" sz="1600" dirty="0">
+                <a:solidFill>
+                  <a:srgbClr val="1F1409"/>
+                </a:solidFill>
+                <a:latin typeface="Calibri" pitchFamily="34" charset="0"/>
+                <a:ea typeface="Calibri" pitchFamily="34" charset="-122"/>
+                <a:cs typeface="Calibri" pitchFamily="34" charset="-120"/>
+              </a:rPr>
+              <a:t> </a:t>
+            </a:r>
+            <a:r>
+              <a:rPr lang="en-US" sz="1600" dirty="0">
+                <a:solidFill>
+                  <a:srgbClr val="1F1409"/>
+                </a:solidFill>
+                <a:latin typeface="Calibri" pitchFamily="34" charset="0"/>
+                <a:ea typeface="Calibri" pitchFamily="34" charset="-122"/>
+                <a:cs typeface="Calibri" pitchFamily="34" charset="-120"/>
+              </a:rPr>
+              <a:t>r3 </a:t>
+            </a:r>
+            <a:r>
+              <a:rPr lang="en-US" sz="1600" dirty="0" err="1">
+                <a:solidFill>
+                  <a:srgbClr val="1F1409"/>
+                </a:solidFill>
+                <a:latin typeface="Calibri" pitchFamily="34" charset="0"/>
+                <a:ea typeface="Calibri" pitchFamily="34" charset="-122"/>
+                <a:cs typeface="Calibri" pitchFamily="34" charset="-120"/>
+              </a:rPr>
+              <a:t>ibm_pittsburgh</a:t>
+            </a:r>
+            <a:r>
+              <a:rPr lang="en-US" sz="1600" dirty="0">
+                <a:solidFill>
+                  <a:srgbClr val="1F1409"/>
+                </a:solidFill>
+                <a:latin typeface="Calibri" pitchFamily="34" charset="0"/>
+                <a:ea typeface="Calibri" pitchFamily="34" charset="-122"/>
+                <a:cs typeface="Calibri" pitchFamily="34" charset="-120"/>
+              </a:rPr>
+              <a:t>)</a:t>
+            </a:r>
           </a:p>
           <a:p>
             <a:pPr marL="342900" indent="-342900">
@@ -1963,7 +2114,7 @@
               <a:buChar char="•"/>
             </a:pPr>
             <a:r>
-              <a:rPr lang="en-US" dirty="0" err="1">
+              <a:rPr lang="en-US" sz="1600" dirty="0" err="1">
                 <a:solidFill>
                   <a:srgbClr val="1F1409"/>
                 </a:solidFill>
@@ -1974,17 +2125,38 @@
               <a:t>SqDRIFT</a:t>
             </a:r>
             <a:r>
-              <a:rPr lang="en-US" dirty="0">
-                <a:solidFill>
-                  <a:srgbClr val="1F1409"/>
-                </a:solidFill>
-                <a:latin typeface="Calibri" pitchFamily="34" charset="0"/>
-                <a:ea typeface="Calibri" pitchFamily="34" charset="-122"/>
-                <a:cs typeface="Calibri" pitchFamily="34" charset="-120"/>
-              </a:rPr>
-              <a:t> - sample-based quantum diagonalization (Trotterized, stochastic drift)</a:t>
-            </a:r>
-            <a:endParaRPr lang="en-US" dirty="0"/>
+              <a:rPr lang="en-US" sz="1600" dirty="0">
+                <a:solidFill>
+                  <a:srgbClr val="1F1409"/>
+                </a:solidFill>
+                <a:latin typeface="Calibri" pitchFamily="34" charset="0"/>
+                <a:ea typeface="Calibri" pitchFamily="34" charset="-122"/>
+                <a:cs typeface="Calibri" pitchFamily="34" charset="-120"/>
+              </a:rPr>
+              <a:t> - sample-based quantum diagonalization (</a:t>
+            </a:r>
+            <a:r>
+              <a:rPr lang="en-US" sz="1600" dirty="0" err="1">
+                <a:solidFill>
+                  <a:srgbClr val="1F1409"/>
+                </a:solidFill>
+                <a:latin typeface="Calibri" pitchFamily="34" charset="0"/>
+                <a:ea typeface="Calibri" pitchFamily="34" charset="-122"/>
+                <a:cs typeface="Calibri" pitchFamily="34" charset="-120"/>
+              </a:rPr>
+              <a:t>Trotterized</a:t>
+            </a:r>
+            <a:r>
+              <a:rPr lang="en-US" sz="1600" dirty="0">
+                <a:solidFill>
+                  <a:srgbClr val="1F1409"/>
+                </a:solidFill>
+                <a:latin typeface="Calibri" pitchFamily="34" charset="0"/>
+                <a:ea typeface="Calibri" pitchFamily="34" charset="-122"/>
+                <a:cs typeface="Calibri" pitchFamily="34" charset="-120"/>
+              </a:rPr>
+              <a:t>, stochastic drift)</a:t>
+            </a:r>
           </a:p>
           <a:p>
             <a:pPr marL="342900" indent="-342900">
@@ -1995,7 +2167,7 @@
               <a:buChar char="•"/>
             </a:pPr>
             <a:r>
-              <a:rPr lang="en-US" dirty="0">
+              <a:rPr lang="en-US" sz="1600" dirty="0">
                 <a:solidFill>
                   <a:srgbClr val="1F1409"/>
                 </a:solidFill>
@@ -2005,7 +2177,6 @@
               </a:rPr>
               <a:t>Empirical anchor: 32-electron / 100-qubit C₁₃Cl₂ benchmark (IBM Research 2026, arXiv:2603.08696)</a:t>
             </a:r>
-            <a:endParaRPr lang="en-US" dirty="0"/>
           </a:p>
           <a:p>
             <a:pPr marL="342900" indent="-342900">
@@ -2015,78 +2186,17 @@
               <a:buSzPct val="100000"/>
               <a:buChar char="•"/>
             </a:pPr>
-            <a:endParaRPr lang="en-US" dirty="0"/>
-            <a:r>
-              <a:rPr lang="en-US" dirty="0">
-                <a:solidFill>
-                  <a:srgbClr val="1F1409"/>
-                </a:solidFill>
-                <a:latin typeface="Calibri" pitchFamily="34" charset="0"/>
-                <a:ea typeface="Calibri" pitchFamily="34" charset="-122"/>
-                <a:cs typeface="Calibri" pitchFamily="34" charset="-120"/>
-              </a:rPr>
-              <a:t>IBM $10B+ roadmap · Starling 2029: 200 logical qubits · C275F (88q) within trajectory</a:t>
-            </a:r>
-          </a:p>
-          <a:p>
-            <a:r>
-              <a:t>Heron r3 spec: IBM Quantum, Processor types &amp; 2026-01 product update (ibm_pittsburgh).</a:t>
-            </a:r>
-          </a:p>
-        </p:txBody>
-      </p:sp>
-      <p:sp>
-        <p:nvSpPr>
-          <p:cNvPr id="31" name="Text 26"/>
-          <p:cNvSpPr/>
-          <p:nvPr/>
-        </p:nvSpPr>
-        <p:spPr>
-          <a:xfrm>
-            <a:off x="10561320" y="10433304"/>
-            <a:ext cx="11795760" cy="365760"/>
-          </a:xfrm>
-          <a:prstGeom prst="rect">
-            <a:avLst/>
-          </a:prstGeom>
-          <a:noFill/>
-          <a:ln w="15875">
-            <a:solidFill>
-              <a:srgbClr val="C00000"/>
-            </a:solidFill>
-            <a:prstDash val="lgDash"/>
-          </a:ln>
-        </p:spPr>
-        <p:txBody>
-          <a:bodyPr wrap="square" lIns="0" tIns="0" rIns="0" bIns="0" rtlCol="0" anchor="ctr"/>
-          <a:lstStyle/>
-          <a:p>
-            <a:pPr marL="0" indent="0" algn="ctr">
-              <a:buNone/>
-            </a:pPr>
-            <a:r>
-              <a:rPr lang="en-US" sz="1600" b="1" kern="0" spc="300" dirty="0">
-                <a:solidFill>
-                  <a:srgbClr val="5C4A37"/>
-                </a:solidFill>
-                <a:latin typeface="Calibri" pitchFamily="34" charset="0"/>
-                <a:ea typeface="Calibri" pitchFamily="34" charset="-122"/>
-                <a:cs typeface="Calibri" pitchFamily="34" charset="-120"/>
-              </a:rPr>
-              <a:t>DSR PHASE 4 EVALUATION*  -  </a:t>
-            </a:r>
-            <a:r>
-              <a:rPr lang="en-US" sz="1600" i="1" dirty="0">
-                <a:solidFill>
-                  <a:srgbClr val="5C4A37"/>
-                </a:solidFill>
-                <a:latin typeface="Calibri" pitchFamily="34" charset="0"/>
-                <a:ea typeface="Calibri" pitchFamily="34" charset="-122"/>
-                <a:cs typeface="Calibri" pitchFamily="34" charset="-120"/>
-              </a:rPr>
-              <a:t>Triangulated · Pre-registered · n=4–6 expert panel</a:t>
-            </a:r>
-            <a:endParaRPr lang="en-US" sz="1600" dirty="0"/>
+            <a:r>
+              <a:rPr lang="en-US" sz="1600" dirty="0">
+                <a:solidFill>
+                  <a:srgbClr val="1F1409"/>
+                </a:solidFill>
+                <a:latin typeface="Calibri" pitchFamily="34" charset="0"/>
+                <a:ea typeface="Calibri" pitchFamily="34" charset="-122"/>
+                <a:cs typeface="Calibri" pitchFamily="34" charset="-120"/>
+              </a:rPr>
+              <a:t>IBM roadmap · Starling 2029: 200 logical qubits · C275F (24–56q) within trajectory</a:t>
+            </a:r>
           </a:p>
         </p:txBody>
       </p:sp>
@@ -2118,7 +2228,7 @@
           <a:bodyPr/>
           <a:lstStyle/>
           <a:p>
-            <a:pPr marL="0" algn="r" defTabSz="914400" rtl="1" eaLnBrk="1" latinLnBrk="0" hangingPunct="1"/>
+            <a:pPr marL="0" algn="l" defTabSz="914400" rtl="0" eaLnBrk="1" latinLnBrk="0" hangingPunct="1"/>
             <a:endParaRPr lang="en-US"/>
           </a:p>
         </p:txBody>
@@ -2224,8 +2334,8 @@
         </p:nvSpPr>
         <p:spPr>
           <a:xfrm>
-            <a:off x="23180040" y="5984548"/>
-            <a:ext cx="8961120" cy="1371600"/>
+            <a:off x="23180039" y="5984548"/>
+            <a:ext cx="8100061" cy="1371600"/>
           </a:xfrm>
           <a:prstGeom prst="rect">
             <a:avLst/>
@@ -2237,9 +2347,6 @@
           <a:bodyPr wrap="square" lIns="0" tIns="0" rIns="0" bIns="0" rtlCol="0" anchor="ctr"/>
           <a:lstStyle/>
           <a:p>
-            <a:pPr marL="0" indent="0">
-              <a:buNone/>
-            </a:pPr>
             <a:r>
               <a:rPr lang="en-US" sz="2000" dirty="0">
                 <a:solidFill>
@@ -2271,7 +2378,7 @@
                 <a:ea typeface="Calibri" pitchFamily="34" charset="-122"/>
                 <a:cs typeface="Calibri" pitchFamily="34" charset="-120"/>
               </a:rPr>
-              <a:t>. 3D molecular viewer · 7 validated core mutations · four-screen workflow.</a:t>
+              <a:t>. 3D molecular viewer · 8 DMRG-classified targets · six-screen workflow.</a:t>
             </a:r>
             <a:endParaRPr lang="en-US" sz="2000" dirty="0"/>
           </a:p>
@@ -2285,8 +2392,8 @@
         </p:nvSpPr>
         <p:spPr>
           <a:xfrm>
-            <a:off x="23180040" y="7481380"/>
-            <a:ext cx="8961120" cy="2103120"/>
+            <a:off x="23180040" y="7181313"/>
+            <a:ext cx="8961120" cy="2754707"/>
           </a:xfrm>
           <a:prstGeom prst="rect">
             <a:avLst/>
@@ -2314,7 +2421,7 @@
                 <a:ea typeface="Calibri" pitchFamily="34" charset="-122"/>
                 <a:cs typeface="Calibri" pitchFamily="34" charset="-120"/>
               </a:rPr>
-              <a:t>7 core mutations</a:t>
+              <a:t>8 DMRG-classified targets - </a:t>
             </a:r>
             <a:r>
               <a:rPr lang="en-US" sz="2000" dirty="0">
@@ -2325,7 +2432,7 @@
                 <a:ea typeface="Calibri" pitchFamily="34" charset="-122"/>
                 <a:cs typeface="Calibri" pitchFamily="34" charset="-120"/>
               </a:rPr>
-              <a:t> - TP53 C275F, KEAP1 LOF, KEAP1 G333C, KEAP1 R320Q, STK11 LKB1, STK11 F354L, STK11 D194N; extensible to 25+ tumor-suppressor genes (expansion pipeline)</a:t>
+              <a:t>TP53 C275F, R175H, G245S, R249S, R282W, KEAP1 G333C, STK11 D194N, SETD2 R1625C; all measured Class B.</a:t>
             </a:r>
             <a:endParaRPr lang="en-US" sz="2000" dirty="0"/>
           </a:p>
@@ -2378,7 +2485,7 @@
                 <a:ea typeface="Calibri" pitchFamily="34" charset="-122"/>
                 <a:cs typeface="Calibri" pitchFamily="34" charset="-120"/>
               </a:rPr>
-              <a:t>P1–P9 audit-trace emission</a:t>
+              <a:t>P1-P9 audit-trace emission</a:t>
             </a:r>
             <a:r>
               <a:rPr lang="en-US" sz="2000" dirty="0">
@@ -2453,7 +2560,29 @@
                 <a:ea typeface="Calibri" pitchFamily="34" charset="-122"/>
                 <a:cs typeface="Calibri" pitchFamily="34" charset="-120"/>
               </a:rPr>
-              <a:t> (Qiskit live · CUDA-Q-compatible design)</a:t>
+              <a:t> (</a:t>
+            </a:r>
+            <a:r>
+              <a:rPr lang="en-US" sz="2000" dirty="0" err="1">
+                <a:solidFill>
+                  <a:srgbClr val="1F1409"/>
+                </a:solidFill>
+                <a:latin typeface="Calibri" pitchFamily="34" charset="0"/>
+                <a:ea typeface="Calibri" pitchFamily="34" charset="-122"/>
+                <a:cs typeface="Calibri" pitchFamily="34" charset="-120"/>
+              </a:rPr>
+              <a:t>Qiskit</a:t>
+            </a:r>
+            <a:r>
+              <a:rPr lang="en-US" sz="2000" dirty="0">
+                <a:solidFill>
+                  <a:srgbClr val="1F1409"/>
+                </a:solidFill>
+                <a:latin typeface="Calibri" pitchFamily="34" charset="0"/>
+                <a:ea typeface="Calibri" pitchFamily="34" charset="-122"/>
+                <a:cs typeface="Calibri" pitchFamily="34" charset="-120"/>
+              </a:rPr>
+              <a:t> live today · CUDA-Q-compatible for Heron r3)</a:t>
             </a:r>
             <a:endParaRPr lang="en-US" sz="2000" dirty="0"/>
           </a:p>
@@ -2506,7 +2635,7 @@
         </p:nvSpPr>
         <p:spPr>
           <a:xfrm>
-            <a:off x="457200" y="10881360"/>
+            <a:off x="499755" y="10879878"/>
             <a:ext cx="16002000" cy="5394960"/>
           </a:xfrm>
           <a:prstGeom prst="rect">
@@ -2526,6 +2655,7 @@
           <a:bodyPr/>
           <a:lstStyle/>
           <a:p>
+            <a:pPr marL="0" algn="r" defTabSz="914400" rtl="1" eaLnBrk="1" latinLnBrk="0" hangingPunct="1"/>
             <a:endParaRPr lang="en-US"/>
           </a:p>
         </p:txBody>
@@ -2808,7 +2938,7 @@
                 <a:ea typeface="Calibri" pitchFamily="34" charset="-122"/>
                 <a:cs typeface="Calibri" pitchFamily="34" charset="-120"/>
               </a:rPr>
-              <a:t>~88-qubit BQP target </a:t>
+              <a:t>24–56-qubit BQP target </a:t>
             </a:r>
             <a:r>
               <a:rPr lang="en-US" sz="2000" dirty="0">
@@ -2833,8 +2963,8 @@
         </p:nvSpPr>
         <p:spPr>
           <a:xfrm>
-            <a:off x="16687800" y="10881360"/>
-            <a:ext cx="15773400" cy="5394960"/>
+            <a:off x="16821795" y="10908792"/>
+            <a:ext cx="15773400" cy="5861947"/>
           </a:xfrm>
           <a:prstGeom prst="rect">
             <a:avLst/>
@@ -2853,6 +2983,7 @@
           <a:bodyPr/>
           <a:lstStyle/>
           <a:p>
+            <a:pPr marL="0" algn="r" defTabSz="914400" rtl="1" eaLnBrk="1" latinLnBrk="0" hangingPunct="1"/>
             <a:endParaRPr lang="en-US"/>
           </a:p>
         </p:txBody>
@@ -2952,29 +3083,6 @@
           </a:p>
         </p:txBody>
       </p:sp>
-      <p:pic>
-        <p:nvPicPr>
-          <p:cNvPr id="47" name="Image 4" descr="benchmarking.jpg"/>
-          <p:cNvPicPr>
-            <a:picLocks noChangeAspect="1"/>
-          </p:cNvPicPr>
-          <p:nvPr/>
-        </p:nvPicPr>
-        <p:blipFill>
-          <a:blip r:embed="rId6"/>
-          <a:srcRect/>
-          <a:stretch/>
-        </p:blipFill>
-        <p:spPr>
-          <a:xfrm>
-            <a:off x="24551640" y="11649456"/>
-            <a:ext cx="7635239" cy="4489703"/>
-          </a:xfrm>
-          <a:prstGeom prst="rect">
-            <a:avLst/>
-          </a:prstGeom>
-        </p:spPr>
-      </p:pic>
       <p:sp>
         <p:nvSpPr>
           <p:cNvPr id="48" name="Text 41"/>
@@ -3094,7 +3202,7 @@
                 <a:ea typeface="Calibri" pitchFamily="34" charset="-122"/>
                 <a:cs typeface="Calibri" pitchFamily="34" charset="-120"/>
               </a:rPr>
-              <a:t>sqDRIFT (Phase 3B target)</a:t>
+              <a:t>sqDRIFT</a:t>
             </a:r>
             <a:r>
               <a:rPr lang="en-US" sz="2000" b="1" dirty="0">
@@ -3105,7 +3213,7 @@
                 <a:ea typeface="Calibri" pitchFamily="34" charset="-122"/>
                 <a:cs typeface="Calibri" pitchFamily="34" charset="-120"/>
               </a:rPr>
-              <a:t>:</a:t>
+              <a:t> (Phase 3B target):</a:t>
             </a:r>
             <a:r>
               <a:rPr lang="en-US" sz="2000" dirty="0">
@@ -3116,7 +3224,7 @@
                 <a:ea typeface="Calibri" pitchFamily="34" charset="-122"/>
                 <a:cs typeface="Calibri" pitchFamily="34" charset="-120"/>
               </a:rPr>
-              <a:t> −11.7 kcal/mol  (0.5 error - within chemical accuracy)</a:t>
+              <a:t> ≤1 kcal/mol error</a:t>
             </a:r>
             <a:endParaRPr lang="en-US" sz="2000" dirty="0"/>
           </a:p>
@@ -3198,24 +3306,8 @@
                 <a:ea typeface="Calibri" pitchFamily="34" charset="-122"/>
                 <a:cs typeface="Calibri" pitchFamily="34" charset="-120"/>
               </a:rPr>
-              <a:t> is itself an original IT contribution (§06.i).</a:t>
-            </a:r>
-          </a:p>
-          <a:p>
-            <a:pPr marL="0" indent="0">
-              <a:buNone/>
-            </a:pPr>
-            <a:r>
-              <a:rPr lang="en-US" sz="1600" i="1" dirty="0">
-                <a:solidFill>
-                  <a:srgbClr val="1F1409"/>
-                </a:solidFill>
-                <a:latin typeface="Calibri" pitchFamily="34" charset="0"/>
-                <a:cs typeface="Calibri" pitchFamily="34" charset="-120"/>
-              </a:rPr>
-              <a:t>*Illustrative figures · Chemical accuracy threshold: ≤1 kcal/mol</a:t>
-            </a:r>
-            <a:endParaRPr lang="en-US" sz="1600" dirty="0"/>
+              <a:t> is itself an original IT contribution.</a:t>
+            </a:r>
           </a:p>
         </p:txBody>
       </p:sp>
@@ -3247,6 +3339,7 @@
           <a:bodyPr/>
           <a:lstStyle/>
           <a:p>
+            <a:pPr marL="0" algn="r" defTabSz="914400" rtl="1" eaLnBrk="1" latinLnBrk="0" hangingPunct="1"/>
             <a:endParaRPr lang="en-US"/>
           </a:p>
         </p:txBody>
@@ -3259,7 +3352,7 @@
         </p:nvSpPr>
         <p:spPr>
           <a:xfrm>
-            <a:off x="777240" y="16779240"/>
+            <a:off x="777240" y="16700862"/>
             <a:ext cx="15361920" cy="457200"/>
           </a:xfrm>
           <a:prstGeom prst="rect">
@@ -3298,7 +3391,7 @@
         </p:nvSpPr>
         <p:spPr>
           <a:xfrm>
-            <a:off x="777240" y="17236440"/>
+            <a:off x="777240" y="17131936"/>
             <a:ext cx="15361920" cy="640080"/>
           </a:xfrm>
           <a:prstGeom prst="rect">
@@ -3337,8 +3430,8 @@
         </p:nvSpPr>
         <p:spPr>
           <a:xfrm>
-            <a:off x="777239" y="17772012"/>
-            <a:ext cx="10234472" cy="2103120"/>
+            <a:off x="777239" y="17662701"/>
+            <a:ext cx="14231984" cy="2103120"/>
           </a:xfrm>
           <a:prstGeom prst="rect">
             <a:avLst/>
@@ -3358,7 +3451,7 @@
               <a:buChar char="•"/>
             </a:pPr>
             <a:r>
-              <a:rPr lang="en-US" sz="2000" b="1" dirty="0">
+              <a:rPr lang="en-US" b="1" dirty="0">
                 <a:solidFill>
                   <a:srgbClr val="1F1409"/>
                 </a:solidFill>
@@ -3369,7 +3462,7 @@
               <a:t>Phase 1 · Foundation</a:t>
             </a:r>
             <a:r>
-              <a:rPr lang="en-US" sz="2000" dirty="0">
+              <a:rPr lang="en-US" dirty="0">
                 <a:solidFill>
                   <a:srgbClr val="1F1409"/>
                 </a:solidFill>
@@ -3380,7 +3473,7 @@
               <a:t> - NGS · BQP-relevance · active-space scoping  </a:t>
             </a:r>
             <a:r>
-              <a:rPr lang="en-US" sz="2000" i="1" dirty="0">
+              <a:rPr lang="en-US" i="1" dirty="0">
                 <a:solidFill>
                   <a:srgbClr val="2E7D32"/>
                 </a:solidFill>
@@ -3390,7 +3483,7 @@
               </a:rPr>
               <a:t>✓ complete</a:t>
             </a:r>
-            <a:endParaRPr lang="en-US" sz="2000" dirty="0"/>
+            <a:endParaRPr lang="en-US" dirty="0"/>
           </a:p>
           <a:p>
             <a:pPr marL="342900" indent="-342900">
@@ -3401,7 +3494,7 @@
               <a:buChar char="•"/>
             </a:pPr>
             <a:r>
-              <a:rPr lang="en-US" sz="2000" b="1" dirty="0">
+              <a:rPr lang="en-US" b="1" dirty="0">
                 <a:solidFill>
                   <a:srgbClr val="1F1409"/>
                 </a:solidFill>
@@ -3412,7 +3505,7 @@
               <a:t>Phase 2 · Architecture</a:t>
             </a:r>
             <a:r>
-              <a:rPr lang="en-US" sz="2000" dirty="0">
+              <a:rPr lang="en-US" dirty="0">
                 <a:solidFill>
                   <a:srgbClr val="1F1409"/>
                 </a:solidFill>
@@ -3423,7 +3516,7 @@
               <a:t> - Workflow spec · React/Three.js prototype  </a:t>
             </a:r>
             <a:r>
-              <a:rPr lang="en-US" sz="2000" i="1" dirty="0">
+              <a:rPr lang="en-US" i="1" dirty="0">
                 <a:solidFill>
                   <a:srgbClr val="2E7D32"/>
                 </a:solidFill>
@@ -3433,7 +3526,7 @@
               </a:rPr>
               <a:t>✓ complete</a:t>
             </a:r>
-            <a:endParaRPr lang="en-US" sz="2000" dirty="0"/>
+            <a:endParaRPr lang="en-US" dirty="0"/>
           </a:p>
           <a:p>
             <a:pPr marL="342900" indent="-342900">
@@ -3444,7 +3537,7 @@
               <a:buChar char="•"/>
             </a:pPr>
             <a:r>
-              <a:rPr lang="en-US" sz="2000" b="1" dirty="0">
+              <a:rPr lang="en-US" b="1" dirty="0">
                 <a:solidFill>
                   <a:srgbClr val="1F1409"/>
                 </a:solidFill>
@@ -3455,17 +3548,50 @@
               <a:t>Phase 3A · Live Circuit</a:t>
             </a:r>
             <a:r>
-              <a:rPr lang="en-US" sz="2000" dirty="0">
-                <a:solidFill>
-                  <a:srgbClr val="1F1409"/>
-                </a:solidFill>
-                <a:latin typeface="Calibri" pitchFamily="34" charset="0"/>
-                <a:ea typeface="Calibri" pitchFamily="34" charset="-122"/>
-                <a:cs typeface="Calibri" pitchFamily="34" charset="-120"/>
-              </a:rPr>
-              <a:t> - PennyLane 4-qubit live VQE + ~20e/40q HPC intermediate (NSF ACCESS / USC CARC) · PySCF JW Hamiltonian · May-Aug 2026</a:t>
-            </a:r>
-            <a:endParaRPr lang="en-US" sz="2000" dirty="0"/>
+              <a:rPr lang="en-US" dirty="0">
+                <a:solidFill>
+                  <a:srgbClr val="1F1409"/>
+                </a:solidFill>
+                <a:latin typeface="Calibri" pitchFamily="34" charset="0"/>
+                <a:ea typeface="Calibri" pitchFamily="34" charset="-122"/>
+                <a:cs typeface="Calibri" pitchFamily="34" charset="-120"/>
+              </a:rPr>
+              <a:t> - PennyLane 4-qubit live VQE + 20e/40q HPC run, both complete (LEON-sealed, 2026-08-04) · </a:t>
+            </a:r>
+            <a:r>
+              <a:rPr lang="en-US" dirty="0" err="1">
+                <a:solidFill>
+                  <a:srgbClr val="1F1409"/>
+                </a:solidFill>
+                <a:latin typeface="Calibri" pitchFamily="34" charset="0"/>
+                <a:ea typeface="Calibri" pitchFamily="34" charset="-122"/>
+                <a:cs typeface="Calibri" pitchFamily="34" charset="-120"/>
+              </a:rPr>
+              <a:t>PySCF</a:t>
+            </a:r>
+            <a:r>
+              <a:rPr lang="en-US" dirty="0">
+                <a:solidFill>
+                  <a:srgbClr val="1F1409"/>
+                </a:solidFill>
+                <a:latin typeface="Calibri" pitchFamily="34" charset="0"/>
+                <a:ea typeface="Calibri" pitchFamily="34" charset="-122"/>
+                <a:cs typeface="Calibri" pitchFamily="34" charset="-120"/>
+              </a:rPr>
+              <a:t> JW Hamiltonian </a:t>
+            </a:r>
+            <a:r>
+              <a:rPr lang="en-US" i="1" dirty="0">
+                <a:solidFill>
+                  <a:srgbClr val="2E7D32"/>
+                </a:solidFill>
+                <a:latin typeface="Calibri" pitchFamily="34" charset="0"/>
+                <a:ea typeface="Calibri" pitchFamily="34" charset="-122"/>
+                <a:cs typeface="Calibri" pitchFamily="34" charset="-120"/>
+              </a:rPr>
+              <a:t>✓ complete</a:t>
+            </a:r>
+            <a:endParaRPr lang="en-US" dirty="0"/>
           </a:p>
           <a:p>
             <a:pPr marL="342900" indent="-342900">
@@ -3476,7 +3602,7 @@
               <a:buChar char="•"/>
             </a:pPr>
             <a:r>
-              <a:rPr lang="en-US" sz="2000" b="1" dirty="0">
+              <a:rPr lang="en-US" b="1" dirty="0">
                 <a:solidFill>
                   <a:srgbClr val="1F1409"/>
                 </a:solidFill>
@@ -3487,17 +3613,28 @@
               <a:t>Phase 3B · Heron r3</a:t>
             </a:r>
             <a:r>
-              <a:rPr lang="en-US" sz="2000" dirty="0">
-                <a:solidFill>
-                  <a:srgbClr val="1F1409"/>
-                </a:solidFill>
-                <a:latin typeface="Calibri" pitchFamily="34" charset="0"/>
-                <a:ea typeface="Calibri" pitchFamily="34" charset="-122"/>
-                <a:cs typeface="Calibri" pitchFamily="34" charset="-120"/>
-              </a:rPr>
-              <a:t>Full ~88-qubit active site · C275F only · proven feasible (94q, Merz et al. 2026) · KEAP1/STK11: fault-tolerant QPU (~2030+) · 152–310q · PDB-verified</a:t>
-            </a:r>
-            <a:endParaRPr lang="en-US" sz="2000" dirty="0"/>
+              <a:rPr lang="he-IL" b="1" dirty="0">
+                <a:solidFill>
+                  <a:srgbClr val="1F1409"/>
+                </a:solidFill>
+                <a:latin typeface="Calibri" pitchFamily="34" charset="0"/>
+                <a:ea typeface="Calibri" pitchFamily="34" charset="-122"/>
+                <a:cs typeface="Calibri" pitchFamily="34" charset="-120"/>
+              </a:rPr>
+              <a:t> - </a:t>
+            </a:r>
+            <a:r>
+              <a:rPr lang="en-US" dirty="0">
+                <a:solidFill>
+                  <a:srgbClr val="1F1409"/>
+                </a:solidFill>
+                <a:latin typeface="Calibri" pitchFamily="34" charset="0"/>
+                <a:ea typeface="Calibri" pitchFamily="34" charset="-122"/>
+                <a:cs typeface="Calibri" pitchFamily="34" charset="-120"/>
+              </a:rPr>
+              <a:t>C275F: 24–56q active site, DMRG Class B · proven feasible (94q, Merz et al. 2026) · KEAP1/STK11: current-era, 32–74q, DMRG Class B · PDB-verified</a:t>
+            </a:r>
+            <a:endParaRPr lang="en-US" dirty="0"/>
           </a:p>
           <a:p>
             <a:pPr marL="342900" indent="-342900">
@@ -3508,7 +3645,7 @@
               <a:buChar char="•"/>
             </a:pPr>
             <a:r>
-              <a:rPr lang="en-US" sz="2000" b="1" dirty="0">
+              <a:rPr lang="en-US" b="1" dirty="0">
                 <a:solidFill>
                   <a:srgbClr val="1F1409"/>
                 </a:solidFill>
@@ -3519,7 +3656,7 @@
               <a:t>Phase 4 · DSR Evaluation</a:t>
             </a:r>
             <a:r>
-              <a:rPr lang="en-US" sz="2000" dirty="0">
+              <a:rPr lang="en-US" dirty="0">
                 <a:solidFill>
                   <a:srgbClr val="1F1409"/>
                 </a:solidFill>
@@ -3529,7 +3666,7 @@
               </a:rPr>
               <a:t> - 4 layers · OSF pre-registered · n=4-6 panel · Jan-Apr 2027</a:t>
             </a:r>
-            <a:endParaRPr lang="en-US" sz="2000" dirty="0"/>
+            <a:endParaRPr lang="en-US" dirty="0"/>
           </a:p>
           <a:p>
             <a:pPr marL="342900" indent="-342900">
@@ -3540,7 +3677,7 @@
               <a:buChar char="•"/>
             </a:pPr>
             <a:r>
-              <a:rPr lang="en-US" sz="2000" b="1" dirty="0">
+              <a:rPr lang="en-US" b="1" dirty="0">
                 <a:solidFill>
                   <a:srgbClr val="1F1409"/>
                 </a:solidFill>
@@ -3551,7 +3688,7 @@
               <a:t>Phase 5 · Synthesis &amp; Defense</a:t>
             </a:r>
             <a:r>
-              <a:rPr lang="en-US" sz="2000" dirty="0">
+              <a:rPr lang="en-US" dirty="0">
                 <a:solidFill>
                   <a:srgbClr val="1F1409"/>
                 </a:solidFill>
@@ -3561,7 +3698,7 @@
               </a:rPr>
               <a:t> - May-Dec 2027</a:t>
             </a:r>
-            <a:endParaRPr lang="en-US" sz="2000" dirty="0"/>
+            <a:endParaRPr lang="en-US" dirty="0"/>
           </a:p>
         </p:txBody>
       </p:sp>
@@ -3573,7 +3710,7 @@
         </p:nvSpPr>
         <p:spPr>
           <a:xfrm>
-            <a:off x="777240" y="19946148"/>
+            <a:off x="1143001" y="19905385"/>
             <a:ext cx="15270480" cy="320040"/>
           </a:xfrm>
           <a:prstGeom prst="rect">
@@ -3586,7 +3723,7 @@
           <a:bodyPr wrap="square" lIns="0" tIns="0" rIns="0" bIns="0" rtlCol="0" anchor="ctr"/>
           <a:lstStyle/>
           <a:p>
-            <a:pPr marL="0" indent="0" algn="l">
+            <a:pPr marL="0" indent="0" algn="ctr">
               <a:buNone/>
             </a:pPr>
             <a:r>
@@ -3612,7 +3749,7 @@
         </p:nvSpPr>
         <p:spPr>
           <a:xfrm>
-            <a:off x="16687800" y="16550640"/>
+            <a:off x="16827500" y="16652240"/>
             <a:ext cx="15773400" cy="3657600"/>
           </a:xfrm>
           <a:prstGeom prst="rect">
@@ -3632,7 +3769,7 @@
           <a:bodyPr/>
           <a:lstStyle/>
           <a:p>
-            <a:pPr marL="0" algn="r" defTabSz="914400" rtl="1" eaLnBrk="1" latinLnBrk="0" hangingPunct="1"/>
+            <a:pPr marL="0" algn="l" defTabSz="914400" rtl="0" eaLnBrk="1" latinLnBrk="0" hangingPunct="1"/>
             <a:endParaRPr lang="en-US"/>
           </a:p>
         </p:txBody>
@@ -3645,7 +3782,7 @@
         </p:nvSpPr>
         <p:spPr>
           <a:xfrm>
-            <a:off x="17007840" y="16779240"/>
+            <a:off x="17007840" y="16609421"/>
             <a:ext cx="15133320" cy="457200"/>
           </a:xfrm>
           <a:prstGeom prst="rect">
@@ -3684,7 +3821,7 @@
         </p:nvSpPr>
         <p:spPr>
           <a:xfrm>
-            <a:off x="17007841" y="17236440"/>
+            <a:off x="17007841" y="17040495"/>
             <a:ext cx="10149840" cy="868680"/>
           </a:xfrm>
           <a:prstGeom prst="rect">
@@ -3729,8 +3866,8 @@
         </p:nvSpPr>
         <p:spPr>
           <a:xfrm>
-            <a:off x="17007839" y="18054588"/>
-            <a:ext cx="12766307" cy="2194560"/>
+            <a:off x="17007839" y="17845580"/>
+            <a:ext cx="14767560" cy="2362660"/>
           </a:xfrm>
           <a:prstGeom prst="rect">
             <a:avLst/>
@@ -3750,38 +3887,25 @@
               <a:buChar char="•"/>
             </a:pPr>
             <a:r>
-              <a:rPr lang="en-US" sz="2000" b="1" dirty="0">
-                <a:solidFill>
-                  <a:srgbClr val="1F1409"/>
-                </a:solidFill>
-                <a:latin typeface="Calibri" pitchFamily="34" charset="0"/>
-                <a:cs typeface="Calibri" pitchFamily="34" charset="-120"/>
-              </a:rPr>
-              <a:t>Proposed </a:t>
-            </a:r>
-            <a:r>
-              <a:rPr lang="en-US" sz="2000" b="1" dirty="0">
-                <a:solidFill>
-                  <a:srgbClr val="1F1409"/>
-                </a:solidFill>
-                <a:latin typeface="Calibri" pitchFamily="34" charset="0"/>
-                <a:ea typeface="Calibri" pitchFamily="34" charset="-122"/>
-                <a:cs typeface="Calibri" pitchFamily="34" charset="-120"/>
-              </a:rPr>
-              <a:t>BQP-relevance classification</a:t>
-            </a:r>
-            <a:r>
-              <a:rPr lang="en-US" sz="2000" dirty="0">
-                <a:solidFill>
-                  <a:srgbClr val="1F1409"/>
-                </a:solidFill>
-                <a:latin typeface="Calibri" pitchFamily="34" charset="0"/>
-                <a:ea typeface="Calibri" pitchFamily="34" charset="-122"/>
-                <a:cs typeface="Calibri" pitchFamily="34" charset="-120"/>
-              </a:rPr>
-              <a:t> for non-druggable oncology targets - reusable across mutation classes</a:t>
-            </a:r>
-            <a:endParaRPr lang="en-US" sz="2000" dirty="0"/>
+              <a:rPr lang="en-US" b="1" dirty="0">
+                <a:solidFill>
+                  <a:srgbClr val="1F1409"/>
+                </a:solidFill>
+                <a:latin typeface="Calibri" pitchFamily="34" charset="0"/>
+                <a:cs typeface="Calibri" pitchFamily="34" charset="-120"/>
+              </a:rPr>
+              <a:t>Proposed BQP-relevance </a:t>
+            </a:r>
+            <a:r>
+              <a:rPr lang="en-US" dirty="0">
+                <a:solidFill>
+                  <a:srgbClr val="1F1409"/>
+                </a:solidFill>
+                <a:latin typeface="Calibri" pitchFamily="34" charset="0"/>
+                <a:cs typeface="Calibri" pitchFamily="34" charset="-120"/>
+              </a:rPr>
+              <a:t>classification for non-druggable oncology targets - reusable across mutation classes</a:t>
+            </a:r>
           </a:p>
           <a:p>
             <a:pPr marL="342900" indent="-342900">
@@ -3792,72 +3916,15 @@
               <a:buChar char="•"/>
             </a:pPr>
             <a:r>
-              <a:rPr lang="en-US" sz="2000" dirty="0">
-                <a:solidFill>
-                  <a:srgbClr val="1F1409"/>
-                </a:solidFill>
-                <a:latin typeface="Calibri" pitchFamily="34" charset="0"/>
-                <a:ea typeface="Calibri" pitchFamily="34" charset="-122"/>
-                <a:cs typeface="Calibri" pitchFamily="34" charset="-120"/>
-              </a:rPr>
-              <a:t>Unlike quantum-</a:t>
-            </a:r>
-            <a:r>
-              <a:rPr lang="en-US" sz="2000" i="1" dirty="0">
-                <a:solidFill>
-                  <a:srgbClr val="1F1409"/>
-                </a:solidFill>
-                <a:latin typeface="Calibri" pitchFamily="34" charset="0"/>
-                <a:ea typeface="Calibri" pitchFamily="34" charset="-122"/>
-                <a:cs typeface="Calibri" pitchFamily="34" charset="-120"/>
-              </a:rPr>
-              <a:t>enhanced</a:t>
-            </a:r>
-            <a:r>
-              <a:rPr lang="en-US" sz="2000" dirty="0">
-                <a:solidFill>
-                  <a:srgbClr val="1F1409"/>
-                </a:solidFill>
-                <a:latin typeface="Calibri" pitchFamily="34" charset="0"/>
-                <a:ea typeface="Calibri" pitchFamily="34" charset="-122"/>
-                <a:cs typeface="Calibri" pitchFamily="34" charset="-120"/>
-              </a:rPr>
-              <a:t> approaches targeting classically-tractable proteins (e.g. KRAS — Vakili et al., </a:t>
-            </a:r>
-            <a:r>
-              <a:rPr lang="en-US" sz="2000" i="1" dirty="0">
-                <a:solidFill>
-                  <a:srgbClr val="1F1409"/>
-                </a:solidFill>
-                <a:latin typeface="Calibri" pitchFamily="34" charset="0"/>
-                <a:ea typeface="Calibri" pitchFamily="34" charset="-122"/>
-                <a:cs typeface="Calibri" pitchFamily="34" charset="-120"/>
-              </a:rPr>
-              <a:t>Nature Biotechnology</a:t>
-            </a:r>
-            <a:r>
-              <a:rPr lang="en-US" sz="2000" dirty="0">
-                <a:solidFill>
-                  <a:srgbClr val="1F1409"/>
-                </a:solidFill>
-                <a:latin typeface="Calibri" pitchFamily="34" charset="0"/>
-                <a:ea typeface="Calibri" pitchFamily="34" charset="-122"/>
-                <a:cs typeface="Calibri" pitchFamily="34" charset="-120"/>
-              </a:rPr>
-              <a:t> 2025), classical methods here become computationally prohibitive at chemical accuracy</a:t>
-            </a:r>
-            <a:r>
-              <a:rPr lang="en-US" sz="2000" b="1" dirty="0">
-                <a:solidFill>
-                  <a:srgbClr val="1F1409"/>
-                </a:solidFill>
-                <a:latin typeface="Calibri" pitchFamily="34" charset="0"/>
-                <a:ea typeface="Calibri" pitchFamily="34" charset="-122"/>
-                <a:cs typeface="Calibri" pitchFamily="34" charset="-120"/>
-              </a:rPr>
-              <a:t/>
-            </a:r>
-            <a:endParaRPr lang="en-US" sz="2000" dirty="0"/>
+              <a:rPr lang="en-US" dirty="0">
+                <a:solidFill>
+                  <a:srgbClr val="1F1409"/>
+                </a:solidFill>
+                <a:latin typeface="Calibri" pitchFamily="34" charset="0"/>
+                <a:cs typeface="Calibri" pitchFamily="34" charset="-120"/>
+              </a:rPr>
+              <a:t>Unlike quantum-enhanced approaches targeting classically-tractable proteins (e.g. KRAS — Vakili et al., Nature Biotechnology 2025), quantum necessity here is established empirically, not assumed - a DMRG classifier tests every target before any quantum claim is made</a:t>
+            </a:r>
           </a:p>
           <a:p>
             <a:pPr marL="342900" indent="-342900">
@@ -3868,60 +3935,25 @@
               <a:buChar char="•"/>
             </a:pPr>
             <a:r>
-              <a:rPr lang="en-US" sz="2000" b="1" dirty="0">
-                <a:solidFill>
-                  <a:srgbClr val="1F1409"/>
-                </a:solidFill>
-                <a:latin typeface="Calibri" pitchFamily="34" charset="0"/>
-                <a:cs typeface="Calibri" pitchFamily="34" charset="-120"/>
-              </a:rPr>
-              <a:t>Novel</a:t>
-            </a:r>
-            <a:r>
-              <a:rPr lang="en-US" sz="2000" b="1" dirty="0">
-                <a:solidFill>
-                  <a:srgbClr val="1F1409"/>
-                </a:solidFill>
-                <a:latin typeface="Calibri" pitchFamily="34" charset="0"/>
-                <a:ea typeface="Calibri" pitchFamily="34" charset="-122"/>
-                <a:cs typeface="Calibri" pitchFamily="34" charset="-120"/>
-              </a:rPr>
-              <a:t> Part-11 compliance framework</a:t>
-            </a:r>
-            <a:r>
-              <a:rPr lang="en-US" sz="2000" dirty="0">
-                <a:solidFill>
-                  <a:srgbClr val="1F1409"/>
-                </a:solidFill>
-                <a:latin typeface="Calibri" pitchFamily="34" charset="0"/>
-                <a:ea typeface="Calibri" pitchFamily="34" charset="-122"/>
-                <a:cs typeface="Calibri" pitchFamily="34" charset="-120"/>
-              </a:rPr>
-              <a:t> for probabilistic quantum binding data (incl. </a:t>
-            </a:r>
-            <a:r>
-              <a:rPr lang="en-US" sz="2000" i="1" dirty="0">
-                <a:solidFill>
-                  <a:srgbClr val="C75A2E"/>
-                </a:solidFill>
-                <a:latin typeface="Calibri" pitchFamily="34" charset="0"/>
-                <a:ea typeface="Calibri" pitchFamily="34" charset="-122"/>
-                <a:cs typeface="Calibri" pitchFamily="34" charset="-120"/>
-              </a:rPr>
-              <a:t>P9 ML-decoder provenance</a:t>
-            </a:r>
-            <a:r>
-              <a:rPr lang="en-US" sz="2000" dirty="0">
-                <a:solidFill>
-                  <a:srgbClr val="1F1409"/>
-                </a:solidFill>
-                <a:latin typeface="Calibri" pitchFamily="34" charset="0"/>
-                <a:ea typeface="Calibri" pitchFamily="34" charset="-122"/>
-                <a:cs typeface="Calibri" pitchFamily="34" charset="-120"/>
-              </a:rPr>
-              <a:t>)</a:t>
-            </a:r>
-            <a:endParaRPr lang="en-US" sz="2000" dirty="0"/>
+              <a:rPr lang="en-US" b="1" dirty="0">
+                <a:solidFill>
+                  <a:srgbClr val="1F1409"/>
+                </a:solidFill>
+                <a:latin typeface="Calibri" pitchFamily="34" charset="0"/>
+                <a:cs typeface="Calibri" pitchFamily="34" charset="-120"/>
+              </a:rPr>
+              <a:t>Novel Part-11 compliance framework </a:t>
+            </a:r>
+            <a:r>
+              <a:rPr lang="en-US" dirty="0">
+                <a:solidFill>
+                  <a:srgbClr val="1F1409"/>
+                </a:solidFill>
+                <a:latin typeface="Calibri" pitchFamily="34" charset="0"/>
+                <a:cs typeface="Calibri" pitchFamily="34" charset="-120"/>
+              </a:rPr>
+              <a:t>for probabilistic quantum binding data (incl. P9 ML-decoder provenance)</a:t>
+            </a:r>
           </a:p>
           <a:p>
             <a:pPr marL="342900" indent="-342900">
@@ -3932,28 +3964,25 @@
               <a:buChar char="•"/>
             </a:pPr>
             <a:r>
-              <a:rPr lang="en-US" sz="2000" b="1" dirty="0">
-                <a:solidFill>
-                  <a:srgbClr val="1F1409"/>
-                </a:solidFill>
-                <a:latin typeface="Calibri" pitchFamily="34" charset="0"/>
-                <a:ea typeface="Calibri" pitchFamily="34" charset="-122"/>
-                <a:cs typeface="Calibri" pitchFamily="34" charset="-120"/>
-              </a:rPr>
-              <a:t>Bifurcation-aware orchestration</a:t>
-            </a:r>
-            <a:r>
-              <a:rPr lang="en-US" sz="2000" dirty="0">
-                <a:solidFill>
-                  <a:srgbClr val="1F1409"/>
-                </a:solidFill>
-                <a:latin typeface="Calibri" pitchFamily="34" charset="0"/>
-                <a:ea typeface="Calibri" pitchFamily="34" charset="-122"/>
-                <a:cs typeface="Calibri" pitchFamily="34" charset="-120"/>
-              </a:rPr>
-              <a:t> surviving the IBM-QCS vs Nvidia-NVQLink vendor split</a:t>
-            </a:r>
-            <a:endParaRPr lang="en-US" sz="2000" dirty="0"/>
+              <a:rPr lang="en-US" b="1" dirty="0">
+                <a:solidFill>
+                  <a:srgbClr val="1F1409"/>
+                </a:solidFill>
+                <a:latin typeface="Calibri" pitchFamily="34" charset="0"/>
+                <a:cs typeface="Calibri" pitchFamily="34" charset="-120"/>
+              </a:rPr>
+              <a:t>Bifurcation-aware orchestration </a:t>
+            </a:r>
+            <a:r>
+              <a:rPr lang="en-US" dirty="0">
+                <a:solidFill>
+                  <a:srgbClr val="1F1409"/>
+                </a:solidFill>
+                <a:latin typeface="Calibri" pitchFamily="34" charset="0"/>
+                <a:cs typeface="Calibri" pitchFamily="34" charset="-120"/>
+              </a:rPr>
+              <a:t>- CPU and GPU (NVIDIA L40S) backends both provisioned on Laguna; GPU path proven at benchmark scale, not yet production-scale</a:t>
+            </a:r>
           </a:p>
           <a:p>
             <a:pPr marL="342900" indent="-342900">
@@ -3964,73 +3993,46 @@
               <a:buChar char="•"/>
             </a:pPr>
             <a:r>
-              <a:rPr lang="en-US" sz="2000" b="1" dirty="0">
-                <a:solidFill>
-                  <a:srgbClr val="1F1409"/>
-                </a:solidFill>
-                <a:latin typeface="Calibri" pitchFamily="34" charset="0"/>
-                <a:ea typeface="Calibri" pitchFamily="34" charset="-122"/>
-                <a:cs typeface="Calibri" pitchFamily="34" charset="-120"/>
-              </a:rPr>
-              <a:t>Selective computational escalation</a:t>
-            </a:r>
-            <a:r>
-              <a:rPr lang="en-US" sz="2000" dirty="0">
-                <a:solidFill>
-                  <a:srgbClr val="1F1409"/>
-                </a:solidFill>
-                <a:latin typeface="Calibri" pitchFamily="34" charset="0"/>
-                <a:ea typeface="Calibri" pitchFamily="34" charset="-122"/>
-                <a:cs typeface="Calibri" pitchFamily="34" charset="-120"/>
-              </a:rPr>
-              <a:t> - formal routing of subproblems to AI / HPC / QC</a:t>
-            </a:r>
-            <a:endParaRPr lang="en-US" sz="2000" dirty="0"/>
-          </a:p>
-          <a:p>
-            <a:pPr marL="342900" indent="-342900">
-              <a:spcAft>
-                <a:spcPts val="400"/>
-              </a:spcAft>
-              <a:buSzPct val="100000"/>
-              <a:buChar char="•"/>
-            </a:pPr>
-            <a:r>
-              <a:rPr lang="en-US" sz="2000" b="1" i="1" dirty="0">
-                <a:solidFill>
-                  <a:srgbClr val="C7361A"/>
-                </a:solidFill>
-                <a:latin typeface="Calibri" pitchFamily="34" charset="0"/>
-                <a:ea typeface="Calibri" pitchFamily="34" charset="-122"/>
-                <a:cs typeface="Calibri" pitchFamily="34" charset="-120"/>
-              </a:rPr>
-              <a:t>Future research:</a:t>
-            </a:r>
-            <a:r>
-              <a:rPr lang="en-US" sz="2000" i="1" dirty="0">
-                <a:solidFill>
-                  <a:srgbClr val="1F1409"/>
-                </a:solidFill>
-                <a:latin typeface="Calibri" pitchFamily="34" charset="0"/>
-                <a:ea typeface="Calibri" pitchFamily="34" charset="-122"/>
-                <a:cs typeface="Calibri" pitchFamily="34" charset="-120"/>
-              </a:rPr>
-              <a:t> NGS-informed radiotherapy decision support (post-doc) - extending GARD-class radiogenomic models</a:t>
-            </a:r>
-            <a:endParaRPr lang="en-US" sz="2000" dirty="0"/>
-          </a:p>
-        </p:txBody>
-      </p:sp>
-      <p:sp>
-        <p:nvSpPr>
-          <p:cNvPr id="60" name="Text 53"/>
-          <p:cNvSpPr/>
-          <p:nvPr/>
-        </p:nvSpPr>
-        <p:spPr>
-          <a:xfrm>
-            <a:off x="457200" y="20299680"/>
-            <a:ext cx="11887200" cy="320040"/>
+              <a:rPr lang="en-US" b="1" dirty="0">
+                <a:solidFill>
+                  <a:srgbClr val="1F1409"/>
+                </a:solidFill>
+                <a:latin typeface="Calibri" pitchFamily="34" charset="0"/>
+                <a:cs typeface="Calibri" pitchFamily="34" charset="-120"/>
+              </a:rPr>
+              <a:t>Selective computational escalation </a:t>
+            </a:r>
+            <a:r>
+              <a:rPr lang="en-US" dirty="0">
+                <a:solidFill>
+                  <a:srgbClr val="1F1409"/>
+                </a:solidFill>
+                <a:latin typeface="Calibri" pitchFamily="34" charset="0"/>
+                <a:cs typeface="Calibri" pitchFamily="34" charset="-120"/>
+              </a:rPr>
+              <a:t>- formal routing of subproblems to AI / HPC / QC</a:t>
+            </a:r>
+            <a:endParaRPr lang="en-US" dirty="0">
+              <a:solidFill>
+                <a:srgbClr val="1F1409"/>
+              </a:solidFill>
+              <a:latin typeface="Calibri" pitchFamily="34" charset="0"/>
+              <a:ea typeface="Calibri" pitchFamily="34" charset="-122"/>
+              <a:cs typeface="Calibri" pitchFamily="34" charset="-120"/>
+            </a:endParaRPr>
+          </a:p>
+        </p:txBody>
+      </p:sp>
+      <p:sp>
+        <p:nvSpPr>
+          <p:cNvPr id="62" name="Text 55"/>
+          <p:cNvSpPr/>
+          <p:nvPr/>
+        </p:nvSpPr>
+        <p:spPr>
+          <a:xfrm>
+            <a:off x="14630399" y="20369349"/>
+            <a:ext cx="2272937" cy="914400"/>
           </a:xfrm>
           <a:prstGeom prst="rect">
             <a:avLst/>
@@ -4039,37 +4041,42 @@
           <a:ln/>
         </p:spPr>
         <p:txBody>
-          <a:bodyPr wrap="square" lIns="0" tIns="0" rIns="0" bIns="0" rtlCol="0" anchor="ctr"/>
-          <a:lstStyle/>
-          <a:p>
-            <a:pPr marL="0" indent="0">
+          <a:bodyPr wrap="square" lIns="0" tIns="0" rIns="0" bIns="0" rtlCol="0" anchor="ctr">
+            <a:normAutofit lnSpcReduction="10000"/>
+          </a:bodyPr>
+          <a:lstStyle/>
+          <a:p>
+            <a:pPr marL="0" indent="0" algn="ctr">
               <a:buNone/>
             </a:pPr>
             <a:r>
-              <a:rPr lang="en-US" sz="1600" b="1" kern="0" spc="500" dirty="0">
-                <a:solidFill>
-                  <a:srgbClr val="5C4A37"/>
-                </a:solidFill>
-                <a:latin typeface="Calibri" pitchFamily="34" charset="0"/>
-                <a:ea typeface="Calibri" pitchFamily="34" charset="-122"/>
-                <a:cs typeface="Calibri" pitchFamily="34" charset="-120"/>
-              </a:rPr>
-              <a:t>FUTURE RESEARCH DIRECTION</a:t>
-            </a:r>
-            <a:endParaRPr lang="en-US" sz="1600" dirty="0"/>
-          </a:p>
-        </p:txBody>
-      </p:sp>
-      <p:sp>
-        <p:nvSpPr>
-          <p:cNvPr id="61" name="Text 54"/>
-          <p:cNvSpPr/>
-          <p:nvPr/>
-        </p:nvSpPr>
-        <p:spPr>
-          <a:xfrm>
-            <a:off x="457200" y="20416065"/>
-            <a:ext cx="11887200" cy="1005840"/>
+              <a:rPr lang="he-IL" sz="6400" b="1" dirty="0">
+                <a:solidFill>
+                  <a:srgbClr val="C75A2E"/>
+                </a:solidFill>
+                <a:latin typeface="David" panose="020E0502060401010101" pitchFamily="34" charset="-79"/>
+                <a:ea typeface="Georgia" pitchFamily="34" charset="-122"/>
+                <a:cs typeface="David" panose="020E0502060401010101" pitchFamily="34" charset="-79"/>
+              </a:rPr>
+              <a:t>56</a:t>
+            </a:r>
+            <a:endParaRPr lang="en-US" sz="6400" dirty="0">
+              <a:latin typeface="David" panose="020E0502060401010101" pitchFamily="34" charset="-79"/>
+              <a:cs typeface="David" panose="020E0502060401010101" pitchFamily="34" charset="-79"/>
+            </a:endParaRPr>
+          </a:p>
+        </p:txBody>
+      </p:sp>
+      <p:sp>
+        <p:nvSpPr>
+          <p:cNvPr id="63" name="Text 56"/>
+          <p:cNvSpPr/>
+          <p:nvPr/>
+        </p:nvSpPr>
+        <p:spPr>
+          <a:xfrm>
+            <a:off x="13845654" y="21077474"/>
+            <a:ext cx="4114800" cy="457200"/>
           </a:xfrm>
           <a:prstGeom prst="rect">
             <a:avLst/>
@@ -4081,22 +4088,88 @@
           <a:bodyPr wrap="square" lIns="0" tIns="0" rIns="0" bIns="0" rtlCol="0" anchor="ctr"/>
           <a:lstStyle/>
           <a:p>
-            <a:pPr marL="0" indent="0">
+            <a:pPr algn="ctr"/>
+            <a:r>
+              <a:rPr lang="en-US" sz="1600" dirty="0">
+                <a:solidFill>
+                  <a:srgbClr val="5C4A37"/>
+                </a:solidFill>
+                <a:latin typeface="Calibri" pitchFamily="34" charset="0"/>
+                <a:ea typeface="Calibri" pitchFamily="34" charset="-122"/>
+                <a:cs typeface="Calibri" pitchFamily="34" charset="-120"/>
+              </a:rPr>
+              <a:t>C275F's largest AVAS-tested active space · within Heron r3 capacity</a:t>
+            </a:r>
+            <a:endParaRPr lang="en-US" sz="1600" dirty="0"/>
+          </a:p>
+        </p:txBody>
+      </p:sp>
+      <p:sp>
+        <p:nvSpPr>
+          <p:cNvPr id="64" name="Text 57"/>
+          <p:cNvSpPr/>
+          <p:nvPr/>
+        </p:nvSpPr>
+        <p:spPr>
+          <a:xfrm>
+            <a:off x="23030596" y="20311907"/>
+            <a:ext cx="743803" cy="831885"/>
+          </a:xfrm>
+          <a:prstGeom prst="rect">
+            <a:avLst/>
+          </a:prstGeom>
+          <a:noFill/>
+          <a:ln/>
+        </p:spPr>
+        <p:txBody>
+          <a:bodyPr wrap="square" lIns="0" tIns="0" rIns="0" bIns="0" rtlCol="0" anchor="ctr"/>
+          <a:lstStyle/>
+          <a:p>
+            <a:pPr marL="0" indent="0" algn="r">
               <a:buNone/>
             </a:pPr>
             <a:r>
-              <a:rPr lang="en-US" sz="1600" b="1" dirty="0">
-                <a:solidFill>
-                  <a:srgbClr val="1F1409"/>
-                </a:solidFill>
-                <a:latin typeface="Calibri" pitchFamily="34" charset="0"/>
-                <a:ea typeface="Calibri" pitchFamily="34" charset="-122"/>
-                <a:cs typeface="Calibri" pitchFamily="34" charset="-120"/>
-              </a:rPr>
-              <a:t>NGS-informed radiotherapy decision support — </a:t>
-            </a:r>
-            <a:r>
-              <a:rPr lang="en-US" sz="1600" i="1" dirty="0">
+              <a:rPr lang="he-IL" sz="6400" b="1" dirty="0">
+                <a:solidFill>
+                  <a:srgbClr val="C75A2E"/>
+                </a:solidFill>
+                <a:latin typeface="David" panose="020E0502060401010101" pitchFamily="34" charset="-79"/>
+                <a:ea typeface="Georgia" pitchFamily="34" charset="-122"/>
+                <a:cs typeface="David" panose="020E0502060401010101" pitchFamily="34" charset="-79"/>
+              </a:rPr>
+              <a:t>8</a:t>
+            </a:r>
+            <a:endParaRPr lang="en-US" sz="6400" dirty="0">
+              <a:latin typeface="David" panose="020E0502060401010101" pitchFamily="34" charset="-79"/>
+              <a:cs typeface="David" panose="020E0502060401010101" pitchFamily="34" charset="-79"/>
+            </a:endParaRPr>
+          </a:p>
+        </p:txBody>
+      </p:sp>
+      <p:sp>
+        <p:nvSpPr>
+          <p:cNvPr id="65" name="Text 58"/>
+          <p:cNvSpPr/>
+          <p:nvPr/>
+        </p:nvSpPr>
+        <p:spPr>
+          <a:xfrm>
+            <a:off x="21628285" y="21051254"/>
+            <a:ext cx="4114800" cy="457200"/>
+          </a:xfrm>
+          <a:prstGeom prst="rect">
+            <a:avLst/>
+          </a:prstGeom>
+          <a:noFill/>
+          <a:ln/>
+        </p:spPr>
+        <p:txBody>
+          <a:bodyPr wrap="square" lIns="0" tIns="0" rIns="0" bIns="0" rtlCol="0" anchor="ctr"/>
+          <a:lstStyle/>
+          <a:p>
+            <a:pPr algn="ctr"/>
+            <a:r>
+              <a:rPr lang="en-US" sz="1600" dirty="0">
                 <a:solidFill>
                   <a:srgbClr val="5C4A37"/>
                 </a:solidFill>
@@ -4104,7 +4177,7 @@
                 <a:ea typeface="Calibri" pitchFamily="34" charset="-122"/>
                 <a:cs typeface="Calibri" pitchFamily="34" charset="-120"/>
               </a:rPr>
-              <a:t>quantum-derived mechanistic features for radioresistance in TP53 structural-mutant tumors. Reserved for a post-doctoral program extending the dissertation infrastructure into clinical decision support.</a:t>
+              <a:t>DMRG-classified targets, all Class B</a:t>
             </a:r>
             <a:endParaRPr lang="en-US" sz="1600" dirty="0"/>
           </a:p>
@@ -4112,14 +4185,14 @@
       </p:sp>
       <p:sp>
         <p:nvSpPr>
-          <p:cNvPr id="62" name="Text 55"/>
-          <p:cNvSpPr/>
-          <p:nvPr/>
-        </p:nvSpPr>
-        <p:spPr>
-          <a:xfrm>
-            <a:off x="14630400" y="20330160"/>
-            <a:ext cx="1828800" cy="914400"/>
+          <p:cNvPr id="66" name="Text 59"/>
+          <p:cNvSpPr/>
+          <p:nvPr/>
+        </p:nvSpPr>
+        <p:spPr>
+          <a:xfrm>
+            <a:off x="26517600" y="20180220"/>
+            <a:ext cx="4114800" cy="914400"/>
           </a:xfrm>
           <a:prstGeom prst="rect">
             <a:avLst/>
@@ -4143,7 +4216,7 @@
                 <a:ea typeface="Georgia" pitchFamily="34" charset="-122"/>
                 <a:cs typeface="Georgia" pitchFamily="34" charset="-120"/>
               </a:rPr>
-              <a:t>~88</a:t>
+              <a:t>100%</a:t>
             </a:r>
             <a:endParaRPr lang="en-US" sz="6400" dirty="0"/>
           </a:p>
@@ -4151,14 +4224,14 @@
       </p:sp>
       <p:sp>
         <p:nvSpPr>
-          <p:cNvPr id="63" name="Text 56"/>
-          <p:cNvSpPr/>
-          <p:nvPr/>
-        </p:nvSpPr>
-        <p:spPr>
-          <a:xfrm>
-            <a:off x="13845654" y="21077474"/>
-            <a:ext cx="4114800" cy="457200"/>
+          <p:cNvPr id="67" name="Text 60"/>
+          <p:cNvSpPr/>
+          <p:nvPr/>
+        </p:nvSpPr>
+        <p:spPr>
+          <a:xfrm>
+            <a:off x="27520710" y="21070191"/>
+            <a:ext cx="4620449" cy="457200"/>
           </a:xfrm>
           <a:prstGeom prst="rect">
             <a:avLst/>
@@ -4170,9 +4243,7 @@
           <a:bodyPr wrap="square" lIns="0" tIns="0" rIns="0" bIns="0" rtlCol="0" anchor="ctr"/>
           <a:lstStyle/>
           <a:p>
-            <a:pPr marL="0" indent="0" algn="ctr">
-              <a:buNone/>
-            </a:pPr>
+            <a:pPr algn="ctr"/>
             <a:r>
               <a:rPr lang="en-US" sz="1600" dirty="0">
                 <a:solidFill>
@@ -4182,7 +4253,7 @@
                 <a:ea typeface="Calibri" pitchFamily="34" charset="-122"/>
                 <a:cs typeface="Calibri" pitchFamily="34" charset="-120"/>
               </a:rPr>
-              <a:t>Qubits at full active site (IBM Heron r3 range)</a:t>
+              <a:t>of measured targets converged to Class B (8/8, DMRG)</a:t>
             </a:r>
             <a:endParaRPr lang="en-US" sz="1600" dirty="0"/>
           </a:p>
@@ -4190,169 +4261,13 @@
       </p:sp>
       <p:sp>
         <p:nvSpPr>
-          <p:cNvPr id="64" name="Text 57"/>
-          <p:cNvSpPr/>
-          <p:nvPr/>
-        </p:nvSpPr>
-        <p:spPr>
-          <a:xfrm>
-            <a:off x="23030596" y="20220466"/>
-            <a:ext cx="743803" cy="831885"/>
-          </a:xfrm>
-          <a:prstGeom prst="rect">
-            <a:avLst/>
-          </a:prstGeom>
-          <a:noFill/>
-          <a:ln/>
-        </p:spPr>
-        <p:txBody>
-          <a:bodyPr wrap="square" lIns="0" tIns="0" rIns="0" bIns="0" rtlCol="0" anchor="ctr"/>
-          <a:lstStyle/>
-          <a:p>
-            <a:pPr marL="0" indent="0" algn="r">
-              <a:buNone/>
-            </a:pPr>
-            <a:r>
-              <a:rPr lang="en-US" sz="6400" b="1" dirty="0">
-                <a:solidFill>
-                  <a:srgbClr val="C75A2E"/>
-                </a:solidFill>
-                <a:latin typeface="Georgia" pitchFamily="34" charset="0"/>
-                <a:ea typeface="Georgia" pitchFamily="34" charset="-122"/>
-                <a:cs typeface="Georgia" pitchFamily="34" charset="-120"/>
-              </a:rPr>
-              <a:t>7</a:t>
-            </a:r>
-            <a:endParaRPr lang="en-US" sz="6400" dirty="0"/>
-          </a:p>
-        </p:txBody>
-      </p:sp>
-      <p:sp>
-        <p:nvSpPr>
-          <p:cNvPr id="65" name="Text 58"/>
-          <p:cNvSpPr/>
-          <p:nvPr/>
-        </p:nvSpPr>
-        <p:spPr>
-          <a:xfrm>
-            <a:off x="21628285" y="21051254"/>
-            <a:ext cx="4114800" cy="457200"/>
-          </a:xfrm>
-          <a:prstGeom prst="rect">
-            <a:avLst/>
-          </a:prstGeom>
-          <a:noFill/>
-          <a:ln/>
-        </p:spPr>
-        <p:txBody>
-          <a:bodyPr wrap="square" lIns="0" tIns="0" rIns="0" bIns="0" rtlCol="0" anchor="ctr"/>
-          <a:lstStyle/>
-          <a:p>
-            <a:pPr marL="0" indent="0" algn="ctr">
-              <a:buNone/>
-            </a:pPr>
-            <a:r>
-              <a:rPr lang="en-US" sz="1600" dirty="0">
-                <a:solidFill>
-                  <a:srgbClr val="5C4A37"/>
-                </a:solidFill>
-                <a:latin typeface="Calibri" pitchFamily="34" charset="0"/>
-                <a:ea typeface="Calibri" pitchFamily="34" charset="-122"/>
-                <a:cs typeface="Calibri" pitchFamily="34" charset="-120"/>
-              </a:rPr>
-              <a:t>core non-druggable mutations · 25+ genes platform-wide</a:t>
-            </a:r>
-            <a:endParaRPr lang="en-US" sz="1600" dirty="0"/>
-          </a:p>
-        </p:txBody>
-      </p:sp>
-      <p:sp>
-        <p:nvSpPr>
-          <p:cNvPr id="66" name="Text 59"/>
-          <p:cNvSpPr/>
-          <p:nvPr/>
-        </p:nvSpPr>
-        <p:spPr>
-          <a:xfrm>
-            <a:off x="26517600" y="20253960"/>
-            <a:ext cx="4114800" cy="914400"/>
-          </a:xfrm>
-          <a:prstGeom prst="rect">
-            <a:avLst/>
-          </a:prstGeom>
-          <a:noFill/>
-          <a:ln/>
-        </p:spPr>
-        <p:txBody>
-          <a:bodyPr wrap="square" lIns="0" tIns="0" rIns="0" bIns="0" rtlCol="0" anchor="ctr"/>
-          <a:lstStyle/>
-          <a:p>
-            <a:pPr marL="0" indent="0" algn="r">
-              <a:buNone/>
-            </a:pPr>
-            <a:r>
-              <a:rPr lang="en-US" sz="6400" b="1" dirty="0">
-                <a:solidFill>
-                  <a:srgbClr val="C75A2E"/>
-                </a:solidFill>
-                <a:latin typeface="Georgia" pitchFamily="34" charset="0"/>
-                <a:ea typeface="Georgia" pitchFamily="34" charset="-122"/>
-                <a:cs typeface="Georgia" pitchFamily="34" charset="-120"/>
-              </a:rPr>
-              <a:t>100%</a:t>
-            </a:r>
-            <a:endParaRPr lang="en-US" sz="6400" dirty="0"/>
-          </a:p>
-        </p:txBody>
-      </p:sp>
-      <p:sp>
-        <p:nvSpPr>
-          <p:cNvPr id="67" name="Text 60"/>
-          <p:cNvSpPr/>
-          <p:nvPr/>
-        </p:nvSpPr>
-        <p:spPr>
-          <a:xfrm>
-            <a:off x="27520711" y="21143931"/>
-            <a:ext cx="4114800" cy="457200"/>
-          </a:xfrm>
-          <a:prstGeom prst="rect">
-            <a:avLst/>
-          </a:prstGeom>
-          <a:noFill/>
-          <a:ln/>
-        </p:spPr>
-        <p:txBody>
-          <a:bodyPr wrap="square" lIns="0" tIns="0" rIns="0" bIns="0" rtlCol="0" anchor="ctr"/>
-          <a:lstStyle/>
-          <a:p>
-            <a:pPr marL="0" indent="0" algn="ctr">
-              <a:buNone/>
-            </a:pPr>
-            <a:r>
-              <a:rPr lang="en-US" sz="1600" dirty="0">
-                <a:solidFill>
-                  <a:srgbClr val="5C4A37"/>
-                </a:solidFill>
-                <a:latin typeface="Calibri" pitchFamily="34" charset="0"/>
-                <a:ea typeface="Calibri" pitchFamily="34" charset="-122"/>
-                <a:cs typeface="Calibri" pitchFamily="34" charset="-120"/>
-              </a:rPr>
-              <a:t>of validated core targets with live JW Hamiltonians</a:t>
-            </a:r>
-            <a:endParaRPr lang="en-US" sz="1600" dirty="0"/>
-          </a:p>
-        </p:txBody>
-      </p:sp>
-      <p:sp>
-        <p:nvSpPr>
           <p:cNvPr id="68" name="Shape 61"/>
           <p:cNvSpPr/>
           <p:nvPr/>
         </p:nvSpPr>
         <p:spPr>
           <a:xfrm>
-            <a:off x="0" y="21808440"/>
+            <a:off x="104503" y="21828033"/>
             <a:ext cx="32918400" cy="137160"/>
           </a:xfrm>
           <a:prstGeom prst="rect">
@@ -4367,40 +4282,11 @@
           <a:bodyPr/>
           <a:lstStyle/>
           <a:p>
+            <a:pPr marL="0" algn="r" defTabSz="914400" rtl="1" eaLnBrk="1" latinLnBrk="0" hangingPunct="1"/>
             <a:endParaRPr lang="en-US"/>
           </a:p>
         </p:txBody>
       </p:sp>
-      <p:pic>
-        <p:nvPicPr>
-          <p:cNvPr id="70" name="Picture 69">
-            <a:extLst>
-              <a:ext uri="{FF2B5EF4-FFF2-40B4-BE49-F238E27FC236}">
-                <a16:creationId xmlns:a16="http://schemas.microsoft.com/office/drawing/2014/main" id="{3E56C2E1-9C77-B785-B350-71C053586CD3}"/>
-              </a:ext>
-            </a:extLst>
-          </p:cNvPr>
-          <p:cNvPicPr>
-            <a:picLocks noChangeAspect="1"/>
-          </p:cNvPicPr>
-          <p:nvPr/>
-        </p:nvPicPr>
-        <p:blipFill>
-          <a:blip r:embed="rId7"/>
-          <a:stretch>
-            <a:fillRect/>
-          </a:stretch>
-        </p:blipFill>
-        <p:spPr>
-          <a:xfrm>
-            <a:off x="9409470" y="11649456"/>
-            <a:ext cx="6821129" cy="4489704"/>
-          </a:xfrm>
-          <a:prstGeom prst="rect">
-            <a:avLst/>
-          </a:prstGeom>
-        </p:spPr>
-      </p:pic>
       <p:sp>
         <p:nvSpPr>
           <p:cNvPr id="41" name="TextBox 40">
@@ -4500,8 +4386,8 @@
         </p:nvSpPr>
         <p:spPr>
           <a:xfrm>
-            <a:off x="868680" y="9629429"/>
-            <a:ext cx="7957268" cy="883395"/>
+            <a:off x="868680" y="9095385"/>
+            <a:ext cx="9304020" cy="883395"/>
           </a:xfrm>
           <a:prstGeom prst="rect">
             <a:avLst/>
@@ -4533,18 +4419,15 @@
                 <a:ea typeface="Calibri" pitchFamily="34" charset="-122"/>
                 <a:cs typeface="Calibri" pitchFamily="34" charset="-120"/>
               </a:rPr>
-              <a:t>the fermionic Hamiltonian eigenvalue problem at C275F admits a known BQP-class quantum algorithm; </a:t>
-            </a:r>
-            <a:r>
-              <a:rPr lang="en-US" i="1" dirty="0">
-                <a:solidFill>
-                  <a:srgbClr val="1F1409"/>
-                </a:solidFill>
-                <a:latin typeface="Calibri" pitchFamily="34" charset="0"/>
-                <a:cs typeface="Calibri" pitchFamily="34" charset="-120"/>
-              </a:rPr>
-              <a:t>Classical methods become computationally prohibitive at chemical accuracy</a:t>
-            </a:r>
+              <a:t>the fermionic Hamiltonian eigenvalue problem at C275F admits a known BQP-class quantum algorithm. Real DMRG measurements on today's generic, not-yet-chemist-defined active space, classify Class B (quantum-advantaged) across every target tested. A chemist-defined setup could plausibly shift a target to Class A (quantum-necessary). The architecture is built for either outcome.</a:t>
+            </a:r>
+            <a:endParaRPr lang="en-US" i="1" dirty="0">
+              <a:solidFill>
+                <a:srgbClr val="1F1409"/>
+              </a:solidFill>
+              <a:latin typeface="Calibri" pitchFamily="34" charset="0"/>
+              <a:cs typeface="Calibri" pitchFamily="34" charset="-120"/>
+            </a:endParaRPr>
           </a:p>
         </p:txBody>
       </p:sp>
@@ -4557,7 +4440,7 @@
           <p:nvPr/>
         </p:nvPicPr>
         <p:blipFill>
-          <a:blip r:embed="rId8"/>
+          <a:blip r:embed="rId5"/>
           <a:stretch>
             <a:fillRect/>
           </a:stretch>
@@ -4566,6 +4449,66 @@
           <a:xfrm>
             <a:off x="30540960" y="1874520"/>
             <a:ext cx="1828800" cy="1828800"/>
+          </a:xfrm>
+          <a:prstGeom prst="rect">
+            <a:avLst/>
+          </a:prstGeom>
+        </p:spPr>
+      </p:pic>
+      <p:pic>
+        <p:nvPicPr>
+          <p:cNvPr id="17" name="Picture 16">
+            <a:extLst>
+              <a:ext uri="{FF2B5EF4-FFF2-40B4-BE49-F238E27FC236}">
+                <a16:creationId xmlns:a16="http://schemas.microsoft.com/office/drawing/2014/main" id="{B84AEB68-9390-2AE2-976C-EF9ECB74ED12}"/>
+              </a:ext>
+            </a:extLst>
+          </p:cNvPr>
+          <p:cNvPicPr>
+            <a:picLocks noChangeAspect="1"/>
+          </p:cNvPicPr>
+          <p:nvPr/>
+        </p:nvPicPr>
+        <p:blipFill>
+          <a:blip r:embed="rId6"/>
+          <a:stretch>
+            <a:fillRect/>
+          </a:stretch>
+        </p:blipFill>
+        <p:spPr>
+          <a:xfrm>
+            <a:off x="25727972" y="11600798"/>
+            <a:ext cx="6659255" cy="4730747"/>
+          </a:xfrm>
+          <a:prstGeom prst="rect">
+            <a:avLst/>
+          </a:prstGeom>
+        </p:spPr>
+      </p:pic>
+      <p:pic>
+        <p:nvPicPr>
+          <p:cNvPr id="74" name="Picture 73">
+            <a:extLst>
+              <a:ext uri="{FF2B5EF4-FFF2-40B4-BE49-F238E27FC236}">
+                <a16:creationId xmlns:a16="http://schemas.microsoft.com/office/drawing/2014/main" id="{144D0589-0639-A61B-E246-ED0AF2A3537B}"/>
+              </a:ext>
+            </a:extLst>
+          </p:cNvPr>
+          <p:cNvPicPr>
+            <a:picLocks noChangeAspect="1"/>
+          </p:cNvPicPr>
+          <p:nvPr/>
+        </p:nvPicPr>
+        <p:blipFill>
+          <a:blip r:embed="rId7"/>
+          <a:stretch>
+            <a:fillRect/>
+          </a:stretch>
+        </p:blipFill>
+        <p:spPr>
+          <a:xfrm>
+            <a:off x="9990884" y="11475300"/>
+            <a:ext cx="6389888" cy="4663709"/>
           </a:xfrm>
           <a:prstGeom prst="rect">
             <a:avLst/>

</xml_diff>

<commit_message>
Revert poster wording back to Undruggable per author's deliberate choice
The previous commit changed "Undruggable" to "non-druggable" to match
CLAUDE.md's SOLANGE acronym spelling, but that was the author's own
deliberate wording choice (per advisor Molly Schmid's recommendation),
not an inconsistency to fix. Reverting the four spots that were changed.

Co-Authored-By: Claude Sonnet 5 <noreply@anthropic.com>
Claude-Session: https://claude.ai/code/session_01A9pq3irFsBbc4SXW67DKjF
</commit_message>
<xml_diff>
--- a/arxiv/IST697_Final_Poster.pptx
+++ b/arxiv/IST697_Final_Poster.pptx
@@ -784,7 +784,7 @@
                 </a:solidFill>
                 <a:latin typeface="Georgia" pitchFamily="34" charset="0"/>
               </a:rPr>
-              <a:t> for Quantum Simulation of Non-druggable NSCLC Tumor Suppressor Mutations</a:t>
+              <a:t> for Quantum Simulation of Undruggable NSCLC Tumor Suppressor Mutations</a:t>
             </a:r>
           </a:p>
         </p:txBody>
@@ -1047,7 +1047,7 @@
                 </a:solidFill>
                 <a:latin typeface="Georgia" pitchFamily="34" charset="0"/>
               </a:rPr>
-              <a:t>Non-druggable</a:t>
+              <a:t>Undruggable</a:t>
             </a:r>
             <a:r>
               <a:rPr lang="en-US" sz="2800" b="1" dirty="0">
@@ -1486,7 +1486,7 @@
                 <a:ea typeface="Calibri" pitchFamily="34" charset="-122"/>
                 <a:cs typeface="Calibri" pitchFamily="34" charset="-120"/>
               </a:rPr>
-              <a:t> Patient case MI25-0349 · TP53 C275F · non-druggable tumor-suppressor mutation</a:t>
+              <a:t> Patient case MI25-0349 · TP53 C275F · Undruggable tumor-suppressor mutation</a:t>
             </a:r>
             <a:endParaRPr lang="en-US" dirty="0"/>
           </a:p>
@@ -3904,7 +3904,7 @@
                 <a:latin typeface="Calibri" pitchFamily="34" charset="0"/>
                 <a:cs typeface="Calibri" pitchFamily="34" charset="-120"/>
               </a:rPr>
-              <a:t>classification for non-druggable oncology targets - reusable across mutation classes</a:t>
+              <a:t>classification for undruggable oncology targets - reusable across mutation classes</a:t>
             </a:r>
           </a:p>
           <a:p>

</xml_diff>

<commit_message>
Standardize poster wording to non-druggable, matching CLAUDE.md acronym
After reconsidering Molly's suggested "Undruggable" wording, Doron
decided to keep "non-druggable" throughout, consistent with the N in
the SOLANGE(TM) acronym (Non-druggable Ground-state Energetics). No
change needed to CLAUDE.md itself - it already used this spelling.

Co-Authored-By: Claude Sonnet 5 <noreply@anthropic.com>
Claude-Session: https://claude.ai/code/session_01A9pq3irFsBbc4SXW67DKjF
</commit_message>
<xml_diff>
--- a/arxiv/IST697_Final_Poster.pptx
+++ b/arxiv/IST697_Final_Poster.pptx
@@ -784,7 +784,7 @@
                 </a:solidFill>
                 <a:latin typeface="Georgia" pitchFamily="34" charset="0"/>
               </a:rPr>
-              <a:t> for Quantum Simulation of Undruggable NSCLC Tumor Suppressor Mutations</a:t>
+              <a:t> for Quantum Simulation of Non-druggable NSCLC Tumor Suppressor Mutations</a:t>
             </a:r>
           </a:p>
         </p:txBody>
@@ -1047,7 +1047,7 @@
                 </a:solidFill>
                 <a:latin typeface="Georgia" pitchFamily="34" charset="0"/>
               </a:rPr>
-              <a:t>Undruggable</a:t>
+              <a:t>Non-druggable</a:t>
             </a:r>
             <a:r>
               <a:rPr lang="en-US" sz="2800" b="1" dirty="0">
@@ -1486,7 +1486,7 @@
                 <a:ea typeface="Calibri" pitchFamily="34" charset="-122"/>
                 <a:cs typeface="Calibri" pitchFamily="34" charset="-120"/>
               </a:rPr>
-              <a:t> Patient case MI25-0349 · TP53 C275F · Undruggable tumor-suppressor mutation</a:t>
+              <a:t> Patient case MI25-0349 · TP53 C275F · non-druggable tumor-suppressor mutation</a:t>
             </a:r>
             <a:endParaRPr lang="en-US" dirty="0"/>
           </a:p>
@@ -3904,7 +3904,7 @@
                 <a:latin typeface="Calibri" pitchFamily="34" charset="0"/>
                 <a:cs typeface="Calibri" pitchFamily="34" charset="-120"/>
               </a:rPr>
-              <a:t>classification for undruggable oncology targets - reusable across mutation classes</a:t>
+              <a:t>classification for non-druggable oncology targets - reusable across mutation classes</a:t>
             </a:r>
           </a:p>
           <a:p>

</xml_diff>

<commit_message>
Poster: update title to match the revised dissertation title
Replaces the old descriptive title with the new one decided for the
dissertation cover: "Deciding When Quantum Computation Is Warranted:
A Governed Instrument for Classical-Tractability Adjudication in
Non-Druggable Oncology." Reduced the title's font size (50pt -> 40pt)
since the new title is longer than the old one, to keep it within the
existing title box's height. Also updated the invisible docProps title
metadata for consistency.
</commit_message>
<xml_diff>
--- a/arxiv/IST697_Final_Poster.pptx
+++ b/arxiv/IST697_Final_Poster.pptx
@@ -754,37 +754,22 @@
           <a:p>
             <a:pPr algn="ctr"/>
             <a:r>
-              <a:rPr lang="en-US" sz="5000" b="1" dirty="0">
+              <a:rPr lang="en-US" sz="4000" b="1" dirty="0">
                 <a:solidFill>
                   <a:srgbClr val="C00000"/>
                 </a:solidFill>
                 <a:latin typeface="Georgia" pitchFamily="34" charset="0"/>
               </a:rPr>
-              <a:t>Governed</a:t>
-            </a:r>
-            <a:r>
-              <a:rPr lang="en-US" sz="5000" b="1" dirty="0">
+              <a:t>Deciding</a:t>
+            </a:r>
+            <a:r>
+              <a:rPr lang="en-US" sz="4000" b="1" dirty="0">
                 <a:solidFill>
                   <a:srgbClr val="1F1409"/>
                 </a:solidFill>
                 <a:latin typeface="Georgia" pitchFamily="34" charset="0"/>
               </a:rPr>
-              <a:t> QC-AI-HPC </a:t>
-            </a:r>
-            <a:r>
-              <a:rPr lang="en-US" sz="5000" b="1" dirty="0">
-                <a:latin typeface="Georgia" pitchFamily="34" charset="0"/>
-              </a:rPr>
-              <a:t>Orchestration</a:t>
-            </a:r>
-            <a:r>
-              <a:rPr lang="en-US" sz="5000" b="1" dirty="0">
-                <a:solidFill>
-                  <a:srgbClr val="1F1409"/>
-                </a:solidFill>
-                <a:latin typeface="Georgia" pitchFamily="34" charset="0"/>
-              </a:rPr>
-              <a:t> for Quantum Simulation of Non-druggable NSCLC Tumor Suppressor Mutations</a:t>
+              <a:t> When Quantum Computation Is Warranted: A Governed Instrument for Classical-Tractability Adjudication in Non-Druggable Oncology</a:t>
             </a:r>
           </a:p>
         </p:txBody>

</xml_diff>